<commit_message>
Rewrite slides and speaker notes in plain language
Co-Authored-By: Claude Opus 5.5 <noreply@anthropic.com>
</commit_message>
<xml_diff>
--- a/slides/Q-Router_slides.pptx
+++ b/slides/Q-Router_slides.pptx
@@ -116,28 +116,28 @@
   <p:extLst>
     <p:ext uri="{521415D9-36F7-43E2-AB2F-B90AF26B5E84}">
       <p14:sectionLst xmlns:p14="http://schemas.microsoft.com/office/powerpoint/2010/main">
-        <p14:section name="Problem" id="{ed00f086-2ecb-2405-b122-c42148b735ed}">
+        <p14:section name="Problem" id="{4426df42-12c0-8823-1671-097c7a2a2df4}">
           <p14:sldIdLst>
             <p14:sldId id="256"/>
             <p14:sldId id="257"/>
             <p14:sldId id="258"/>
           </p14:sldIdLst>
         </p14:section>
-        <p14:section name="Approach" id="{9291cc2f-4757-b31b-7c10-f12572be83db}">
+        <p14:section name="Approach" id="{f22ce7e6-6daa-706a-2515-93c7416359ff}">
           <p14:sldIdLst>
             <p14:sldId id="259"/>
             <p14:sldId id="260"/>
             <p14:sldId id="261"/>
           </p14:sldIdLst>
         </p14:section>
-        <p14:section name="Results" id="{452e6310-578b-8ab6-24ec-9e2b3edbd9c7}">
+        <p14:section name="Results" id="{989c8ed6-44a6-456b-fbd3-e7b3e447419d}">
           <p14:sldIdLst>
             <p14:sldId id="262"/>
             <p14:sldId id="263"/>
             <p14:sldId id="264"/>
           </p14:sldIdLst>
         </p14:section>
-        <p14:section name="Wrap-up" id="{5fa74958-acdb-6973-f031-58289f3a9dfc}">
+        <p14:section name="Wrap-up" id="{b4d1c306-454c-a11a-fcad-409ea899bdb2}">
           <p14:sldIdLst>
             <p14:sldId id="265"/>
           </p14:sldIdLst>
@@ -177,7 +177,7 @@
                 </a:solidFill>
                 <a:latin typeface="+mn-lt"/>
               </a:rPr>
-              <a:t>Each piece solved both ways (noisy IBM Torino model)</a:t>
+              <a:t>Score for each piece (on a realistic copy of IBM's chip)</a:t>
             </a:r>
           </a:p>
         </c:rich>
@@ -201,7 +201,7 @@
               <c:strCache>
                 <c:ptCount val="1"/>
                 <c:pt idx="0">
-                  <c:v>Gate-based QAOA</c:v>
+                  <c:v>Gate-based</c:v>
                 </c:pt>
               </c:strCache>
             </c:strRef>
@@ -284,7 +284,7 @@
               <c:strCache>
                 <c:ptCount val="1"/>
                 <c:pt idx="0">
-                  <c:v>Digital anneal</c:v>
+                  <c:v>Annealing</c:v>
                 </c:pt>
               </c:strCache>
             </c:strRef>
@@ -551,7 +551,7 @@
                 </a:solidFill>
                 <a:latin typeface="+mn-lt"/>
               </a:rPr>
-              <a:t>Reusing tuned settings across industries (60 problems)</a:t>
+              <a:t>Copying settings between industries (60 problems)</a:t>
             </a:r>
           </a:p>
         </c:rich>
@@ -662,16 +662,16 @@
                 <c:ptCount val="4"/>
                 <c:lvl>
                   <c:pt idx="0">
-                    <c:v>Tuned from scratch (~60 runs)</c:v>
+                    <c:v>Tuned from scratch (60 tries)</c:v>
                   </c:pt>
                   <c:pt idx="1">
-                    <c:v>Borrowed from twin (1 run)</c:v>
+                    <c:v>Copied from similar problem (1 try)</c:v>
                   </c:pt>
                   <c:pt idx="2">
-                    <c:v>Random donor (1 run)</c:v>
+                    <c:v>Copied from random problem (1 try)</c:v>
                   </c:pt>
                   <c:pt idx="3">
-                    <c:v>Default settings (1 run)</c:v>
+                    <c:v>No tuning at all (1 try)</c:v>
                   </c:pt>
                 </c:lvl>
               </c:multiLvlStrCache>
@@ -1230,14 +1230,14 @@
           <a:p>
             <a:r>
               <a:rPr lang="en-US" dirty="0"/>
-              <a:t>SAY (30 s):
-"Hi, we're Team Q-Router. Quantum computers are now available on the cloud, and there are two very different kinds: gate-based machines like IBM's, and annealers like D-Wave's. Our project answers a simple question: for a given business decision, which quantum computer should solve it, or should it stay on a normal laptop? We built Q-Router to make that decision automatically, and we tested it on finance and healthcare problems, including real IBM hardware."
-ONE-SENTENCE VERSION (if a judge asks for one):
-"Q-Router breaks a business decision into pieces and sends each piece to whichever kind of computer suits its shape: gate-based quantum, annealing quantum, or a classical laptop."
-LIKELY QUESTION: What does 'routing' mean here?
-ANSWER: Choosing which solver gets which problem, or which piece of a problem, the way a GPS chooses car, train or walking for each leg of a trip.
+              <a:t>WHAT TO SAY (30 seconds):
+"Hi, we're Team Q-Router. You can now rent quantum computers over the internet, and there are two very different kinds. Our project answers one simple question: for a given business decision, which kind of quantum computer should solve it, or should a normal laptop do it instead? Q-Router makes that choice automatically. We tested it on money and health decisions, including on a real IBM quantum chip."
+IF A JUDGE ASKS FOR ONE SENTENCE:
+"Q-Router breaks a business decision into pieces and sends each piece to whichever computer suits it best: one of two kinds of quantum computer, or a normal laptop."
+LIKELY QUESTION: What does "routing" mean?
+ANSWER: Choosing where to send each job, like a GPS choosing car, train or walking for each part of a trip.
 LIKELY QUESTION: Who did what on the team?
-ANSWER: (Fill in with real names.) The Builder wrote the Qiskit notebook and ran the hardware jobs; the Domain experts framed the drug-funding problem, wrote USE-CASE.md and LIMITATIONS.md, and built this deck. Everyone can explain the pipeline.</a:t>
+ANSWER: (Fill in real names.) Our coder built the program and ran it on the quantum chip. The rest of the team defined the drug-funding problem, wrote the use-case and limitations documents, and built this presentation. Everyone can explain how it works.</a:t>
             </a:r>
             <a:endParaRPr lang="en-US" dirty="0"/>
           </a:p>
@@ -1325,19 +1325,19 @@
           <a:p>
             <a:r>
               <a:rPr lang="en-US" dirty="0"/>
-              <a:t>SAY (45 s):
-"To wrap up. What's new: choosing gate-based or annealing piece by piece inside one problem; reusing quantum settings across real industries, with a control that proves the matching matters; routing that reads the real chip's noise; and measured compute savings, 4 times fewer quantum shots.
-What's honest: there's no quantum advantage, a laptop wins today; our annealer is imitated on IBM's gate-based chip; our problems are much smaller than real ones; and our noise model undersells the annealer.
-With another month: deeper circuits, where borrowing settings should save much more; a real D-Wave annealer as a third backend; real drug-pipeline data; and we'd watch for hardware with 10 to 100 times lower error, which is roughly what it would take to compete.
-Q-Router knows when and how to use quantum computing, and says honestly that today a laptop still wins. Thank you, we'd love your questions."
-LIKELY QUESTION: What makes your approach different from existing examples?
-ANSWER: Each ingredient exists: QAOA, annealing, solver selection, parameter transfer (a 2025 paper transfers QAOA settings between problem types), and multi-programming. What we didn't find elsewhere is the combination: piece-by-piece gate-vs-anneal routing inside one problem, transfer across real industry decisions with a random-donor control, a chip-noise-aware fingerprint, and the compute it saves, measured on real hardware.
+              <a:t>WHAT TO SAY (45 seconds):
+"To wrap up. What's new: Q-Router picks gate-based or annealing for each piece of a single problem; it learns from one industry to help another, and we proved that with a fair comparison; it uses the real chip's error rates to decide; and it uses 4 times less quantum time.
+What's honest: a normal laptop still wins today; our annealing is a copy built on IBM's chip, not a real D-Wave machine; our tests are tiny compared with real decisions; and our error estimate is too hard on annealing.
+With another month, we'd try bigger recipes, where copying settings should save even more; add a real D-Wave annealing computer; use real drug-trial data; and we'd watch for quantum chips with 10 to 100 times fewer errors, which is roughly what it would take to compete.
+Q-Router knows when and how to use quantum computing, and admits a laptop still wins today. Thank you! We'd love your questions."
+LIKELY QUESTION: What makes your approach different?
+ANSWER: Each piece exists somewhere: the quantum recipes, choosing solvers with AI, copying settings, running several problems on one chip. What we didn't find anywhere is all of it together: choosing gate-based or annealing piece by piece inside one problem, copying settings across real industries with a fair test, using the chip's real error rates, and measuring the quantum time saved on a real chip.
 LIKELY QUESTION: What did you learn?
-ANSWER: That honest scoring matters: our first metric made everything look 0.99 and hid a sign bug. That the 'right' quantum method depends on the problem's shape and the chip's noise, not on which method is better in theory. And how to run real experiments on a 10-minute budget: tune on simulators, batch, and dry-run on a fake device.
+ANSWER: That honest scoring matters: our first score made everything look 99% good and hid a big bug. That the best quantum method depends on the shape of the problem and the chip's errors, not on which method is better in theory. And how to do real experiments with only 10 minutes: tune on a simulator, batch the work, and test on a fake chip first.
 LIKELY QUESTION: What would you do with another month?
-ANSWER: Test deeper circuits, add a real D-Wave backend, use real pipeline data, fix the noise model so the router stops underrating the annealer, and repeat hardware runs for error bars.
+ANSWER: Bigger recipes, a real D-Wave computer, real drug data, a better error estimate so the router stops underrating annealing, and repeated real-chip runs to measure how much results vary.
 LIKELY QUESTION: What did each of you contribute?
-ANSWER: (Fill in with real names and roles.)</a:t>
+ANSWER: (Fill in real names and roles.)</a:t>
             </a:r>
             <a:endParaRPr lang="en-US" dirty="0"/>
           </a:p>
@@ -1425,13 +1425,13 @@
           <a:p>
             <a:r>
               <a:rPr lang="en-US" dirty="0"/>
-              <a:t>SAY (45 s):
-"Here's the problem. Quantum time is scarce: our free IBM plan gives us 10 minutes a month, and companies pay by the second. There are two kinds of quantum computer, gate-based and annealing, and they're good at different shapes of problem. And today's chips are noisy, so if you send the wrong problem to the wrong machine, the answer is no better than a random guess.
-That affects companies experimenting with quantum, like pharma and finance teams; the cloud providers who have to decide where jobs run, which fits this year's theme, a decade of quantum on the cloud; and researchers with small budgets. Today people mostly guess, or fill in a questionnaire like the Next-Step Quantum Decision Guide. Q-Router answers three questions with data: is quantum worth it, which kind, and for which part of the problem."
+              <a:t>WHAT TO SAY (45 seconds):
+"Here's the problem. Quantum time is rare and expensive: our free account gives us 10 minutes a month, and companies pay by the second. There are two kinds of quantum computer, and each is good at different kinds of problems. And today's quantum chips make mistakes, so if you send a problem to the wrong one, the answer is useless.
+This matters to companies trying out quantum, like drug makers and banks; to IBM, D-Wave and Amazon, who rent these machines out and have to decide where each job goes, which fits this year's theme, a decade of quantum on the cloud; and to students and researchers with tiny budgets. Today people mostly guess. Q-Router answers three questions with real data: is quantum worth it, which kind, and for which part of the problem."
 LIKELY QUESTION: What problem are you solving, and for whom?
-ANSWER: Deciding when and how to use quantum computing so scarce quantum time isn't wasted. For companies buying quantum time, for cloud providers routing jobs, and for researchers.
-LIKELY QUESTION: Is this a real problem if classical always wins today?
-ANSWER: Yes. IBM, D-Wave and Amazon already offer several kinds of quantum hardware, and D-Wave's hybrid solvers already split work between classical and quantum behind the scenes. Today the honest answer is usually 'use classical', and our router says so. As chips improve, the decision gets more valuable, and choosing between the two quantum styles already matters for anyone running quantum experiments now.</a:t>
+ANSWER: Knowing when and how to use a quantum computer, so scarce quantum time isn't wasted. It's for companies paying for quantum time, for the companies renting quantum computers out, and for researchers.
+LIKELY QUESTION: Is this a real problem if a laptop wins today?
+ANSWER: Yes. IBM, D-Wave and Amazon already rent out different kinds of quantum computers, and users have to guess which fits. Today the honest answer is usually "use a laptop," and our program says so. As quantum chips improve, that choice becomes more valuable, and choosing between the two quantum kinds already matters for anyone running quantum experiments.</a:t>
             </a:r>
             <a:endParaRPr lang="en-US" dirty="0"/>
           </a:p>
@@ -1519,15 +1519,15 @@
           <a:p>
             <a:r>
               <a:rPr lang="en-US" dirty="0"/>
-              <a:t>SAY (45 s):
-"To test this we needed a real decision. Our flagship is drug funding: a pharma company has 10 drug candidates and money for 4. Each drug has a payoff: its chance of approval times its future sales, minus its development cost. Drugs for the same disease tend to succeed or fail together, so funding two of them adds risk. There are 210 possible groups of 4. This is exactly the portfolio math investors use for stocks, applied to drugs, which is why we call it our finance-times-healthcare problem.
-We write it as a QUBO, one yes/no qubit per drug, and the same format covers three other fields we use: a stock portfolio with real stock prices, choosing diagnostic tests from a real breast-cancer dataset, and splitting a network."
-LIKELY QUESTION: How is this done today?
-ANSWER: Pharma portfolio committees combine expert judgment with spreadsheet scoring and classical optimizers. At realistic sizes, 50 to 200 candidates, classical solvers handle it well.
-LIKELY QUESTION: Is the drug data real?
-ANSWER: The stock prices (Yahoo Finance) and the medical dataset (scikit-learn breast cancer) are real. The drug pipeline is simulated, using approximate industry success rates by trial phase: about 8% for Phase I, 15% Phase II, 55% Phase III. Real pipeline data from ClinicalTrials.gov would be the next step.
-LIKELY QUESTION: What is a QUBO?
-ANSWER: A score sheet for yes/no decisions: points for each yes, and points for each pair of yeses. Lower total is better. Rules like 'exactly 4' are added as a big penalty. Every quantum optimizer in our project takes this one format.</a:t>
+              <a:t>WHAT TO SAY (45 seconds):
+"To test this we needed a real decision. Our main example: a drug company has 10 possible drugs and money to develop 4. Each drug could make a certain amount of money, and costs a certain amount to develop. Drugs for the same disease often succeed or fail together, so funding two of them is riskier. There are 210 different ways to pick 4. The company wants the most money for the least risk. That's the same math investors use to pick stocks, just applied to drugs.
+Each yes-or-no choice, fund this drug or not, becomes one qubit, one quantum bit. We also tested three other kinds of decision so the program can learn patterns: which stocks to buy, using real stock prices; which medical tests to order, using real patient data; and how to split a network into two groups."
+LIKELY QUESTION: How is this decided today?
+ANSWER: Drug companies use expert judgment, spreadsheets and normal computer programs. At real sizes, 50 to 200 drugs, normal computers do this well.
+LIKELY QUESTION: Is the data real?
+ANSWER: The stock prices and the medical test data are real. The drug list is made up, but it uses real industry success rates: early-stage drugs pass about 8% of the time, late-stage about 55%.
+LIKELY QUESTION: How does a decision become something a quantum computer can read?
+ANSWER: We write it as a score sheet of yes/no choices: points for each yes, and points for each pair of yeses (like two risky drugs together). Lower score is better. Rules like "exactly 4" become a big penalty. The technical name is a QUBO.</a:t>
             </a:r>
             <a:endParaRPr lang="en-US" dirty="0"/>
           </a:p>
@@ -1615,17 +1615,19 @@
           <a:p>
             <a:r>
               <a:rPr lang="en-US" dirty="0"/>
-              <a:t>SAY (60 s):
-"Picture the problem as a mountain range: every spot is one combination of drugs, its height is how bad that choice is, and the lowest valley is the best answer.
-An annealer drops a ball and shakes the landscape gently, less and less, so the ball settles into a deep valley. It's slow and steady and needs almost no tuning. D-Wave builds these. IBM doesn't, so we imitate one: we chop the slow sweep into many small gate steps. That's called a digitized anneal, or linear-ramp QAOA, and it has been run on IBM hardware at 100+ qubits.
-A gate-based computer follows a short recipe called QAOA: put every qubit in a mix of yes and no, link the decisions that affect each other with entangling gates, shuffle, and measure. The recipe has dials we tune on a simulator first.
-Why might quantum help? Superposition lets the chip hold every combination at once, entanglement encodes which decisions interact, and sampling gives many good answers. But we're honest about the limits: every gate adds noise, our problems use 3 to 18 qubits while real portfolios need 50 to 200, and there's no proven speedup. At this size a laptop wins."
-LIKELY QUESTION: Why quantum instead of a classical approach?
-ANSWER: For these sizes, classical is better, and we show it. Quantum is interesting because the problem's structure, decisions that interact in pairs, maps directly onto qubits and entangling gates. The open question is whether that pays off at larger sizes on better hardware.
-LIKELY QUESTION: What would need to improve to beat classical?
-ANSWER: Roughly 10 to 100 times lower two-qubit error rates, enough qubits for 50 to 200 variables with all-to-all connections, and evidence of a speedup at those sizes. Our roadmap chart in the notebook shows which industries would cross over first as errors fall.
-LIKELY QUESTION: Is your 'annealer' a real annealer?
-ANSWER: No. It's an anneal digitized into gates on IBM's chip, because we don't have D-Wave access. A real D-Wave backend could be plugged into the same router; that's on our next-steps list.</a:t>
+              <a:t>WHAT TO SAY (60 seconds):
+"Imagine the problem as a mountain range. Every spot is one possible set of drugs, the height is how bad that choice is, and the lowest valley is the best answer.
+An annealing quantum computer works like a ball rolling slowly downhill. It takes many small steps and gradually settles into a low valley. It needs almost no tuning. D-Wave builds these. IBM doesn't, so we copy the same idea on IBM's chip using many small steps.
+A gate-based quantum computer follows a short recipe instead, called QAOA. It has only a few steps, but it has dials that must be tuned first. We tune the dials on a normal computer so we don't waste quantum time.
+Why might quantum help at all? It can hold every combination at once, it can link choices that affect each other, and it gives you many good answers to pick from. But we're honest: every step adds a chance of error, our test problems are tiny compared with real ones, and a normal laptop still wins today."
+LIKELY QUESTION: Why use quantum instead of a normal computer?
+ANSWER: At this size a normal computer is better, and we show that. Quantum is interesting because these decisions, choices that affect each other in pairs, match how qubits link up. The open question is whether that pays off on bigger problems with better chips.
+LIKELY QUESTION: What would need to improve for quantum to win?
+ANSWER: Quantum chips would need to make roughly 10 to 100 times fewer errors, and have enough qubits for 50 to 200 choices. Even then, someone would have to show quantum is actually faster.
+LIKELY QUESTION: Is your annealing a real annealer?
+ANSWER: No. It's a copy of the annealing idea, built from small steps on IBM's chip, because we don't have access to a D-Wave machine. A real D-Wave could plug straight into our program; that's on our next-steps list.
+IF ASKED ABOUT THE TECHNICAL NAMES:
+"Try every combination at once" is called superposition. "Link choices" is called entanglement. "Many good answers" is called sampling. Our copied annealer is called a digitized anneal or linear-ramp QAOA.</a:t>
             </a:r>
             <a:endParaRPr lang="en-US" dirty="0"/>
           </a:p>
@@ -1713,22 +1715,24 @@
           <a:p>
             <a:r>
               <a:rPr lang="en-US" dirty="0"/>
-              <a:t>SAY (75 s):
-"Here's the pipeline.
-One: translate the decision into a QUBO score sheet.
-Two: big problems get broken into pieces of up to 8 decisions, using spectral clustering, which groups the decisions that affect each other most.
-Three: each piece gets a fingerprint of 9 numbers: how many decisions, how connected they are, and, using IBM's own calibration data, how many entangling gates it needs and how likely the chip is to run it without a mistake.
-Four: an AI, a random forest trained on 60 practice problems from all four fields, predicts how well gate-based, annealing and classical will do on that fingerprint, and picks one. If no quantum option is predicted to be worth it, the piece goes to the laptop.
-Five: instead of tuning the quantum dials from scratch, which takes about 60 circuit runs, Q-Router finds the most similar past problem from a different industry and borrows its settings.
-Six: several problems share the chip in one job, and every answer is checked against the exact best answer, which we can compute because the problems are small."
+              <a:t>WHAT TO SAY (75 seconds):
+"Here's how it works, in six steps.
+One: translate the decision into yes-or-no choices.
+Two: if the problem is big, split it into small pieces, keeping choices that affect each other in the same piece.
+Three: describe each piece. How connected are its choices? And, using IBM's own error data, how many errors would the real chip make running it?
+Four: a small AI picks the best computer for each piece: gate-based quantum, annealing quantum, or a normal laptop if quantum isn't worth it. The AI learned this from 60 practice problems that we solved on a simulator, which is a normal computer pretending to be a quantum computer.
+Five: tuning a quantum computer's settings usually takes about 60 tries. Instead, Q-Router finds the most similar problem it has seen, from a different industry, and copies its settings.
+Six: it runs several problems on the chip at the same time, and checks every answer against the true best answer, which we can find because our problems are small."
 LIKELY QUESTION: How does the AI decide?
-ANSWER: It's 300 small decision trees playing 20 questions with the 9 fingerprint numbers, then voting. It learned on its own that 'can the chip afford the annealer's longer circuit?' is the most important question.
-LIKELY QUESTION: How do you find a 'structural twin'?
-ANSWER: A lookup, not training: we put all 60 practice problems' fingerprints on the same scale and pick the closest one from a different industry. Then we copy its tuned dial settings.
-LIKELY QUESTION: How do you score answers fairly?
-ANSWER: We use the average quality of all measurements, not the best single one. With 2,048 measurements and about 1,000 possible answers, the best single shot is almost always optimal, so that would be cheating. 1 means the exact best, 0 means a random guess.
-LIKELY QUESTION: Does the AI pick the drugs?
-ANSWER: No. The AI only picks which solver gets each piece. The solvers find the drugs.</a:t>
+ANSWER: It's 300 small yes/no flowcharts, like games of 20 questions, that vote. It learned by itself that the most important question is: "can the chip handle the annealer's extra steps without too many errors?" The technical name is a random forest.
+LIKELY QUESTION: Were the 60 practice problems run on the real chip?
+ANSWER: No. They were solved on a simulator, three ways each, and we know the true best answer for each. The chip's errors were estimated from IBM's published error rates. The real chip is used only for our final experiments.
+LIKELY QUESTION: How do you find a "similar problem"?
+ANSWER: Each problem is described by 9 numbers. We pick the past problem whose numbers are closest, from a different industry, and copy its settings. It's a lookup, not guessing.
+LIKELY QUESTION: How do you score fairly?
+ANSWER: We average the quality of every answer the chip gives, not just its luckiest one. 1 means the perfect answer, 0 means no better than random.
+LIKELY QUESTION: Does the AI choose the drugs?
+ANSWER: No. The AI only chooses which computer solves each piece. That computer finds the drugs.</a:t>
             </a:r>
             <a:endParaRPr lang="en-US" dirty="0"/>
           </a:p>
@@ -1816,15 +1820,16 @@
           <a:p>
             <a:r>
               <a:rPr lang="en-US" dirty="0"/>
-              <a:t>SAY (45 s):
-"Everything is built in Qiskit. We convert each QUBO into a Pauli operator and build QAOA circuits with QAOAAnsatz. The transpiler compiles them onto IBM Torino's real qubit layout, using its calibration data, which is also where our noise estimates come from. We run everything through the SamplerV2 primitive: on the Aer simulator, on a noisy model of Torino, and on the real chip. On hardware we use dynamical decoupling and Pauli twirling, and in simulation we demonstrate zero-noise extrapolation. Because the free plan has no Sessions, we batch many circuits into single jobs; all our hardware experiments fit in about 3 of our 10 minutes.
-The hardest bug: Qiskit's QAOA starts in the top state of its mixer, so with both angles positive our circuits were searching for the WORST answer. Scores were minus 1.37. Flipping one sign gave 0.79."
-LIKELY QUESTION: Walk me through your circuit.
-ANSWER: Hadamards put every qubit in a 50/50 mix. Then a cost layer: an RZ rotation on each qubit for its own payoff, and an RZZ gate on each pair of interacting decisions, which is where entanglement comes from. Then a mixer layer of RX rotations. Repeat p times, then measure. Gate-QAOA uses p = 1-2 with tuned angles; the digitized anneal uses p = 3-6 with a fixed ramp.
+              <a:t>WHAT TO SAY (45 seconds):
+"We built everything with Qiskit, IBM's free quantum software. It turns each decision into a quantum recipe, rewrites that recipe to fit IBM's real chip, called Torino, and runs the same code on a simulator, on a copy of the chip that imitates its errors, or on the real chip. It tunes the recipe's dials automatically on a normal computer. On the real chip we use tricks that reduce errors. And because our free plan is so limited, we send many recipes in one trip, so all our real-chip experiments use about 3 of our 10 minutes.
+The hardest bug: a plus-or-minus mix-up made our recipe hunt for the worst answer instead of the best. Our score was minus 1.37, worse than random. Flipping one sign gave 0.79. The lesson: always check against a known best answer."
+LIKELY QUESTION: Walk me through your quantum circuit (recipe).
+ANSWER: First, every qubit is put in a 50/50 mix of yes and no. Then each qubit gets a nudge based on how good its choice is, and every pair of linked choices gets a linking step, which is entanglement. Then a shuffle step lets it explore. We repeat that a few times and then measure. Gate-based uses 1-2 rounds with tuned dials; our annealing copy uses 3-6 rounds on a fixed schedule.
 LIKELY QUESTION: What did you build vs. reuse?
-ANSWER: Reused: Qiskit's QAOAAnsatz, transpiler, primitives and Aer; D-Wave's open-source simulated annealer as the classical baseline; scikit-learn's random forest. Built: the four problem encoders, the fingerprint, the router, the twin transfer, the decomposition comparison, the packing experiment, the compute ledger, and the evaluation.
+ANSWER: We reused IBM's Qiskit tools, D-Wave's free normal-computer solver as our comparison, and a standard AI library. We built the four problem translators, the way we describe each problem, the AI router, the settings-copying, the break-down comparison, the run-together experiment, and all the scoring.
 LIKELY QUESTION: What else was hard?
-ANSWER: A simulator quirk: Aer's sampler corrupted results when we batched circuits of different sizes, which faked a huge crosstalk effect. We traced it, and now run local circuits one per job while hardware still uses one batched job.</a:t>
+ANSWER: The simulator gave wrong results when we sent recipes of different sizes in one batch, which made it look like problems were disturbing each other. We tracked it down and now run them one at a time on the simulator; the real chip handles batches correctly.
+TECHNICAL NAMES, IF ASKED: QAOAAnsatz (recipe builder), transpiler (fits the chip), SamplerV2 (runs and measures), Aer (simulator), COBYLA (dial tuner), dynamical decoupling and Pauli twirling (error tricks on the chip), zero-noise extrapolation (error trick in simulation).</a:t>
             </a:r>
             <a:endParaRPr lang="en-US" dirty="0"/>
           </a:p>
@@ -1912,16 +1917,17 @@
           <a:p>
             <a:r>
               <a:rPr lang="en-US" dirty="0"/>
-              <a:t>SAY (60 s), this answers 'when is each quantum type effective when you break the problem down':
-"We built one bigger problem with two very different parts: which drugs to fund, where every decision affects every other one, and how to split clinical-trial sites between two research partners, where each site only interacts with a few neighbors. Q-Router broke it into three pieces, and for this experiment we ran BOTH quantum types on EVERY piece on a noisy model of IBM's Torino chip.
-Gate-based wins the dense drug piece, 0.56 to 0.45. The annealer wins both trial-site pieces, 0.44 to 0.37 and 0.69 to 0.42. Why? The annealer needs many more steps: on the drug piece that's 685 entangling gates versus 99, and noise piles up. On sparse pieces the extra steps are affordable.
-Mixing them is best: the router's mix scores 0.54, beating all-gate at 0.45 and all-anneal at 0.52. The same pattern shows up across all 60 practice problems: annealing almost never wins dense finance and pharma problems, but wins over half of the sparse network problems. Section 9b repeats this on the real chip."
-LIKELY QUESTION: Did the router pick correctly every time?
-ANSWER: Two out of three. It picked gate-based for trial-sites A, where annealing was better. The reason: its noise model is too pessimistic about long annealing circuits; it predicted 0.21 for the anneal there, and the noisy simulation gave 0.44. Fixing that noise model is a next step.
-LIKELY QUESTION: Does the full answer come out right?
-ANSWER: Yes. Reassembling the pieces finds the exact best combination with every strategy. The difference between strategies is in the quality of the samples, which is what matters on noisy hardware.
+              <a:t>WHAT TO SAY (60 seconds). This answers the judge's question about comparing the two kinds of quantum computer piece by piece:
+"We made one bigger problem with two very different parts: which drugs to fund, where every choice affects every other one, and how to split trial sites between two research partners, where each site only affects a few neighbors. Q-Router split it into three pieces, and for this test we solved EVERY piece with BOTH kinds of quantum computer, on a realistic copy of IBM's chip that includes its errors. Scores go from 0, a random guess, to 1, the perfect answer.
+Gate-based wins the drug piece, 0.56 to 0.45. Annealing wins both trial-site pieces, 0.44 to 0.37 and 0.69 to 0.42. Why? Annealing takes many more steps, and every step adds errors. When every choice is linked to every other, that's too many error-prone steps. When choices are only loosely linked, annealing can afford them.
+So the best plan is to mix them. Q-Router's mix scores 0.54, better than gate-based only at 0.45 or annealing only at 0.52. The 60 practice problems show the same pattern: annealing almost never wins on stocks or drugs, where everything is linked, but wins more than half the network problems. We'll also run this exact test on the real chip."
+LIKELY QUESTION: Did Q-Router choose correctly every time?
+ANSWER: Two out of three. It chose gate-based for trial sites A, where annealing was actually better. That's because our error estimate is too pessimistic about annealing's extra steps. Fixing that is a next step.
+LIKELY QUESTION: Do you still get the right final answer?
+ANSWER: Yes. Putting the pieces back together finds the perfect set of drugs with every approach. The difference is how reliably each method lands on good answers, which matters most on an error-prone chip.
 LIKELY QUESTION: Is one example enough?
-ANSWER: The break-down is one illustrative problem. The statistical weight comes from the 60-problem dataset, which shows the same dense-vs-sparse pattern.</a:t>
+ANSWER: This is one example to show the idea. The 60 practice problems give the bigger picture, and they show the same pattern.
+TECHNICAL TERMS, IF ASKED: "every choice affects every other" = a dense problem; "only a few" = sparse. "Realistic copy of the chip" = a noise model built from IBM Torino's calibration data.</a:t>
             </a:r>
             <a:endParaRPr lang="en-US" dirty="0"/>
           </a:p>
@@ -2009,19 +2015,20 @@
           <a:p>
             <a:r>
               <a:rPr lang="en-US" dirty="0"/>
-              <a:t>SAY (60 s):
-"Our second idea is pattern recognition across industries. Tuning a quantum circuit's dials normally takes about 60 runs per problem. Q-Router instead finds a structural twin from a different industry and borrows its settings: one run.
-Across 60 problems, borrowed settings score 0.60, against 0.63 for full tuning. The important control: borrowing from a RANDOM problem in another industry scores 0.58, no better than default settings. So the twin-matching is what does the work. It recovers about half of the tuning gain at 1/60 of the cost.
-Then we combined this with packing: four problems from four industries, grouped by shape, tuned once per group and run together in ONE chip job. That's 4 times fewer quantum shots and 1 job instead of 4, keeping 96% of the quality.
-Two more checks. Entanglement matters: switch off every entangling gate and the score drops from 0.77 to 0.31. And the honest baseline: the classical laptop scores 0.95 to 0.98 on every problem. No quantum advantage at this size, and we don't claim one."
+              <a:t>WHAT TO SAY (60 seconds):
+"Our second idea is learning across industries. Tuning a quantum computer's settings normally takes about 60 tries per problem. Q-Router instead finds a similar problem from a different industry and copies its settings, so it only needs one try.
+Across 60 problems, copied settings score 0.60, close to the 0.63 you get by tuning from scratch. The key check: copying from a RANDOM problem scores 0.58, no better than not tuning at all. So it's the matching of similar problems that makes it work. We get about half the benefit of tuning for one-sixtieth of the effort.
+Then we combined that with running problems together: four problems from four industries, grouped by how similar they are, sharing settings, and sent to the chip in one trip instead of four. That uses 4 times less quantum time and keeps 96% of the quality.
+Two more checks. If we cut the links between qubits, the entanglement, the score drops from 0.77 to 0.31, so quantum linking really matters. And honestly: a normal laptop scores 0.95 to 0.98 every time. Quantum doesn't win yet, and we don't claim it does."
 LIKELY QUESTION: How do you know it worked?
-ANSWER: Every answer is compared to the exact best answer, found by checking every combination. Every quantum result is compared to a classical baseline, to a default-settings baseline, and to a random-donor control. The 60-problem results have standard errors around 0.02.
+ANSWER: We know the perfect answer to every problem, because we checked every combination. We compare every quantum result against a normal laptop, against no tuning, and against copying from a random problem. Across 60 problems the results are consistent, not luck.
 LIKELY QUESTION: What surprised you?
-ANSWER: That the annealer, which looked worse on average, clearly wins sparse pieces; and that our simple noise model is too pessimistic about it. Also that random donors are no better than defaults, which is what convinced us the twin-matching is real.
-LIKELY QUESTION: Isn't reusing QAOA parameters already known?
-ANSWER: Yes, within similar graph problems ('parameter concentration'), and a 2025 paper used machine learning to transfer between problem types. Our contribution is testing it across real industry decisions with real data, with a random-donor control, and combining it with routing and packing to measure compute saved.
-LIKELY QUESTION: Where did the quality loss in one-tune-one-job come from?
-ANSWER: Almost all from one network problem grouped with finance problems. Packing itself cost nothing measurable; crosstalk was about 0.01 in simulation.</a:t>
+ANSWER: That annealing, which looked worse on average, clearly wins on loosely connected pieces. And that copying from a random problem helps not at all, which convinced us the similarity matching is real.
+LIKELY QUESTION: Hasn't copying quantum settings been done before?
+ANSWER: Yes, between similar math problems, and a 2025 study did it between different problem types. What's new in ours: real industry decisions with real data, a fair random-copy comparison, and combining it with choosing the computer and running problems together to measure how much quantum time it saves.
+LIKELY QUESTION: Where did the 4% quality loss come from?
+ANSWER: Almost all from one network problem that got grouped with the stock problems. Running problems side by side cost almost nothing.
+TECHNICAL TERMS, IF ASKED: copying settings = parameter transfer; the random-copy check = a control; "± 0.010" in our notebook is the standard error, meaning the result is reliable.</a:t>
             </a:r>
             <a:endParaRPr lang="en-US" dirty="0"/>
           </a:p>
@@ -2109,18 +2116,20 @@
           <a:p>
             <a:r>
               <a:rPr lang="en-US" dirty="0"/>
-              <a:t>SAY (45 s):
-"This is the hardware bonus tier: real device plus noise analysis. We run the flagship drug problem three ways: a perfect simulator, a noisy model of the chip built from IBM's calibration data, and the real quantum processor, with and without error mitigation, meaning dynamical decoupling and Pauli twirling. [Read the QPU numbers once they are in.]
-Notice the annealer: on a perfect simulator it beats gate-based, 0.81 to 0.74, but its circuit needs 688 entangling gates versus 104, so on a noisy chip it falls behind. That's the whole routing story in one row.
-We also measured noise directly: zero-noise extrapolation, where we amplify noise on purpose and extrapolate back to zero, won back about a quarter of the lost quality.
-All our hardware experiments are batched into seven jobs and use about 3 of our 10 QPU minutes."
-IF THE HARDWARE RUN HAS NOT FINISHED: "Our jobs are queued on IBM's free tier; every hardware cell was first dry-run on a fake IBM Torino, and the noisy-model column is what we expect."
-LIKELY QUESTION: Simulator vs hardware, how big was the gap?
-ANSWER: (Fill in from the table.) Compare the 'noisy chip model' column with 'real QPU raw'. If they're close, our noise model is trustworthy; if the QPU is worse, crosstalk and coherent errors that the model ignores are the likely cause.
-LIKELY QUESTION: Did error mitigation help?
-ANSWER: (Fill in.) Twirling mostly converts coherent errors into random noise rather than removing it, so gains on a sampler are usually modest. We report whatever we measured.
-LIKELY QUESTION: Why not run more on hardware?
-ANSWER: The free plan gives 10 minutes per 28 days, and minutes spent now don't come back before the state final. So we tune everything on simulators and send only final circuits, batched, to the chip.</a:t>
+              <a:t>WHAT TO SAY (45 seconds):
+"Finally, the real chip. We ran the drug problem four ways: on a perfect simulator with no errors, on a copy of IBM's chip that imitates its errors, on the real chip, and on the real chip with error-reducing fixes turned on. [Read the real-chip numbers once they're in.]
+Look at annealing: with no errors it actually beats gate-based, 0.81 to 0.74. But it takes 7 times more of the risky linking steps, 688 versus 104, so once errors are included it falls behind. That one row is the whole reason Q-Router exists.
+We also measured the errors themselves. An error-cancelling trick, where we deliberately add extra errors and work backwards to estimate the error-free answer, won back about a quarter of the lost quality. And running three problems side by side on one chip barely disturbed them.
+All four real-chip tests together use about 3 of our 10 free quantum minutes."
+IF THE REAL-CHIP RUN HASN'T FINISHED:
+"Our jobs are waiting in IBM's free queue. We tested all the code on a fake copy of the chip first, and the 'copy of chip' column shows what we expect."
+LIKELY QUESTION: How did the real chip compare with the simulator?
+ANSWER: (Fill in.) Compare "copy of chip" with "real chip." If they're close, our error estimate is trustworthy. If the real chip is worse, it has kinds of errors our copy doesn't imitate.
+LIKELY QUESTION: Did the error fixes help?
+ANSWER: (Fill in.) The fixes mostly make errors more random so they cancel out, rather than removing them, so the improvement is usually small. We report whatever we measured.
+LIKELY QUESTION: Why not run more on the real chip?
+ANSWER: The free plan gives 10 minutes per 28 days, and minutes we use now won't come back before the state final. So we tune everything on simulators and send only finished recipes, in batches.
+TECHNICAL TERMS, IF ASKED: errors = noise; "copy of chip" = a noise model from IBM Torino's calibration data; the fixes = dynamical decoupling and Pauli twirling; the error-cancelling trick = zero-noise extrapolation; problems disturbing each other = crosstalk (we measured about 0.01).</a:t>
             </a:r>
             <a:endParaRPr lang="en-US" dirty="0"/>
           </a:p>
@@ -3022,7 +3031,7 @@
                   <a:schemeClr val="accent6"/>
                 </a:solidFill>
               </a:rPr>
-              <a:t>Routing finance and healthcare decisions between gate-based and annealing quantum computing, on real IBM hardware</a:t>
+              <a:t>Q-Router picks the right kind of computer for each part of a business decision, and we tested it on a real IBM quantum chip</a:t>
             </a:r>
             <a:endParaRPr lang="en-US" sz="1800" dirty="0"/>
           </a:p>
@@ -3168,7 +3177,7 @@
       </p:sp>
       <p:sp>
         <p:nvSpPr>
-          <p:cNvPr id="8" name="Gate-based box"/>
+          <p:cNvPr id="8" name="Gate-based quantum box"/>
           <p:cNvSpPr/>
           <p:nvPr/>
         </p:nvSpPr>
@@ -3195,7 +3204,7 @@
       </p:sp>
       <p:pic>
         <p:nvPicPr>
-          <p:cNvPr id="9" name="Gate-based icon" descr="preencoded.png">    </p:cNvPr>
+          <p:cNvPr id="9" name="Gate-based quantum icon" descr="preencoded.png">    </p:cNvPr>
           <p:cNvPicPr>
             <a:picLocks noChangeAspect="1"/>
           </p:cNvPicPr>
@@ -3242,14 +3251,14 @@
               <a:buNone/>
             </a:pPr>
             <a:r>
-              <a:rPr lang="en-US" sz="1500" b="1" dirty="0">
+              <a:rPr lang="en-US" sz="1400" b="1" dirty="0">
                 <a:solidFill>
                   <a:schemeClr val="bg1"/>
                 </a:solidFill>
               </a:rPr>
-              <a:t>Gate-based</a:t>
-            </a:r>
-            <a:endParaRPr lang="en-US" sz="1500" dirty="0"/>
+              <a:t>Gate-based quantum</a:t>
+            </a:r>
+            <a:endParaRPr lang="en-US" sz="1400" dirty="0"/>
           </a:p>
         </p:txBody>
       </p:sp>
@@ -3302,7 +3311,7 @@
       </p:sp>
       <p:sp>
         <p:nvSpPr>
-          <p:cNvPr id="13" name="Annealing box"/>
+          <p:cNvPr id="13" name="Annealing quantum box"/>
           <p:cNvSpPr/>
           <p:nvPr/>
         </p:nvSpPr>
@@ -3329,7 +3338,7 @@
       </p:sp>
       <p:pic>
         <p:nvPicPr>
-          <p:cNvPr id="14" name="Annealing icon" descr="preencoded.png">    </p:cNvPr>
+          <p:cNvPr id="14" name="Annealing quantum icon" descr="preencoded.png">    </p:cNvPr>
           <p:cNvPicPr>
             <a:picLocks noChangeAspect="1"/>
           </p:cNvPicPr>
@@ -3376,14 +3385,14 @@
               <a:buNone/>
             </a:pPr>
             <a:r>
-              <a:rPr lang="en-US" sz="1500" b="1" dirty="0">
+              <a:rPr lang="en-US" sz="1400" b="1" dirty="0">
                 <a:solidFill>
                   <a:schemeClr val="bg1"/>
                 </a:solidFill>
               </a:rPr>
-              <a:t>Annealing</a:t>
-            </a:r>
-            <a:endParaRPr lang="en-US" sz="1500" dirty="0"/>
+              <a:t>Annealing quantum</a:t>
+            </a:r>
+            <a:endParaRPr lang="en-US" sz="1400" dirty="0"/>
           </a:p>
         </p:txBody>
       </p:sp>
@@ -3436,7 +3445,7 @@
       </p:sp>
       <p:sp>
         <p:nvSpPr>
-          <p:cNvPr id="18" name="Classical box"/>
+          <p:cNvPr id="18" name="Normal laptop box"/>
           <p:cNvSpPr/>
           <p:nvPr/>
         </p:nvSpPr>
@@ -3463,7 +3472,7 @@
       </p:sp>
       <p:pic>
         <p:nvPicPr>
-          <p:cNvPr id="19" name="Classical icon" descr="preencoded.png">    </p:cNvPr>
+          <p:cNvPr id="19" name="Normal laptop icon" descr="preencoded.png">    </p:cNvPr>
           <p:cNvPicPr>
             <a:picLocks noChangeAspect="1"/>
           </p:cNvPicPr>
@@ -3510,14 +3519,14 @@
               <a:buNone/>
             </a:pPr>
             <a:r>
-              <a:rPr lang="en-US" sz="1500" b="1" dirty="0">
+              <a:rPr lang="en-US" sz="1400" b="1" dirty="0">
                 <a:solidFill>
                   <a:schemeClr val="bg1"/>
                 </a:solidFill>
               </a:rPr>
-              <a:t>Classical</a:t>
-            </a:r>
-            <a:endParaRPr lang="en-US" sz="1500" dirty="0"/>
+              <a:t>Normal laptop</a:t>
+            </a:r>
+            <a:endParaRPr lang="en-US" sz="1400" dirty="0"/>
           </a:p>
         </p:txBody>
       </p:sp>
@@ -3733,7 +3742,7 @@
                   <a:schemeClr val="bg1"/>
                 </a:solidFill>
               </a:rPr>
-              <a:t>Gate vs. anneal chosen piece by piece inside one problem</a:t>
+              <a:t>Picks gate-based or annealing for each piece of one problem</a:t>
             </a:r>
             <a:endParaRPr lang="en-US" sz="1300" dirty="0"/>
           </a:p>
@@ -3751,7 +3760,7 @@
                   <a:schemeClr val="bg1"/>
                 </a:solidFill>
               </a:rPr>
-              <a:t>Settings reused across real industries, with a random-donor control</a:t>
+              <a:t>Learns from one industry to help another, and proves it with a fair test</a:t>
             </a:r>
             <a:endParaRPr lang="en-US" sz="1300" dirty="0"/>
           </a:p>
@@ -3769,7 +3778,7 @@
                   <a:schemeClr val="bg1"/>
                 </a:solidFill>
               </a:rPr>
-              <a:t>Routing that reads the real chip's noise</a:t>
+              <a:t>Uses the real chip's error rates to decide</a:t>
             </a:r>
             <a:endParaRPr lang="en-US" sz="1300" dirty="0"/>
           </a:p>
@@ -3787,7 +3796,7 @@
                   <a:schemeClr val="bg1"/>
                 </a:solidFill>
               </a:rPr>
-              <a:t>Compute savings measured: 4× fewer shots</a:t>
+              <a:t>Uses 4× less quantum time</a:t>
             </a:r>
             <a:endParaRPr lang="en-US" sz="1300" dirty="0"/>
           </a:p>
@@ -3939,7 +3948,7 @@
                   <a:schemeClr val="bg1"/>
                 </a:solidFill>
               </a:rPr>
-              <a:t>No quantum advantage: a laptop wins today</a:t>
+              <a:t>A normal laptop still wins today</a:t>
             </a:r>
             <a:endParaRPr lang="en-US" sz="1300" dirty="0"/>
           </a:p>
@@ -3957,7 +3966,7 @@
                   <a:schemeClr val="bg1"/>
                 </a:solidFill>
               </a:rPr>
-              <a:t>Our anneal is imitated on gates, not a D-Wave</a:t>
+              <a:t>Our annealing is a copy on IBM's chip, not a real D-Wave</a:t>
             </a:r>
             <a:endParaRPr lang="en-US" sz="1300" dirty="0"/>
           </a:p>
@@ -3975,7 +3984,7 @@
                   <a:schemeClr val="bg1"/>
                 </a:solidFill>
               </a:rPr>
-              <a:t>3-18 qubits vs. 50-200 in real portfolios</a:t>
+              <a:t>Our tests are tiny: 3-18 choices vs. 50-200</a:t>
             </a:r>
             <a:endParaRPr lang="en-US" sz="1300" dirty="0"/>
           </a:p>
@@ -3993,7 +4002,7 @@
                   <a:schemeClr val="bg1"/>
                 </a:solidFill>
               </a:rPr>
-              <a:t>The noise model undersells the anneal</a:t>
+              <a:t>Our error estimate underrates annealing</a:t>
             </a:r>
             <a:endParaRPr lang="en-US" sz="1300" dirty="0"/>
           </a:p>
@@ -4145,7 +4154,7 @@
                   <a:schemeClr val="bg1"/>
                 </a:solidFill>
               </a:rPr>
-              <a:t>Deeper circuits, where borrowed settings save more</a:t>
+              <a:t>Bigger recipes, where copying settings saves more</a:t>
             </a:r>
             <a:endParaRPr lang="en-US" sz="1300" dirty="0"/>
           </a:p>
@@ -4163,7 +4172,7 @@
                   <a:schemeClr val="bg1"/>
                 </a:solidFill>
               </a:rPr>
-              <a:t>A real D-Wave annealer as a third backend</a:t>
+              <a:t>Add a real D-Wave annealing computer</a:t>
             </a:r>
             <a:endParaRPr lang="en-US" sz="1300" dirty="0"/>
           </a:p>
@@ -4181,7 +4190,7 @@
                   <a:schemeClr val="bg1"/>
                 </a:solidFill>
               </a:rPr>
-              <a:t>Real pipeline data from ClinicalTrials.gov</a:t>
+              <a:t>Use real drug-trial data</a:t>
             </a:r>
             <a:endParaRPr lang="en-US" sz="1300" dirty="0"/>
           </a:p>
@@ -4199,7 +4208,7 @@
                   <a:schemeClr val="bg1"/>
                 </a:solidFill>
               </a:rPr>
-              <a:t>Needs ~10-100× lower two-qubit error to compete</a:t>
+              <a:t>Chips need about 10-100× fewer errors to compete</a:t>
             </a:r>
             <a:endParaRPr lang="en-US" sz="1300" dirty="0"/>
           </a:p>
@@ -4458,7 +4467,7 @@
                   <a:schemeClr val="tx1"/>
                 </a:solidFill>
               </a:rPr>
-              <a:t>Scarce</a:t>
+              <a:t>Rare and expensive</a:t>
             </a:r>
             <a:endParaRPr lang="en-US" sz="1600" dirty="0"/>
           </a:p>
@@ -4494,7 +4503,7 @@
                   <a:schemeClr val="tx1"/>
                 </a:solidFill>
               </a:rPr>
-              <a:t>10 quantum minutes a month on IBM's free plan; paid time is billed by the second</a:t>
+              <a:t>We get 10 minutes of quantum time a month for free; companies pay by the second</a:t>
             </a:r>
             <a:endParaRPr lang="en-US" sz="1300" dirty="0"/>
           </a:p>
@@ -4642,7 +4651,7 @@
                   <a:schemeClr val="tx1"/>
                 </a:solidFill>
               </a:rPr>
-              <a:t>Gate-based (IBM, Google) and annealing (D-Wave) machines suit different problem shapes</a:t>
+              <a:t>There are two kinds of quantum computer, and each is good at different problems</a:t>
             </a:r>
             <a:endParaRPr lang="en-US" sz="1300" dirty="0"/>
           </a:p>
@@ -4754,7 +4763,7 @@
                   <a:schemeClr val="tx1"/>
                 </a:solidFill>
               </a:rPr>
-              <a:t>Noisy</a:t>
+              <a:t>They make mistakes</a:t>
             </a:r>
             <a:endParaRPr lang="en-US" sz="1600" dirty="0"/>
           </a:p>
@@ -4790,7 +4799,7 @@
                   <a:schemeClr val="tx1"/>
                 </a:solidFill>
               </a:rPr>
-              <a:t>The wrong problem on the wrong chip returns answers no better than a random guess</a:t>
+              <a:t>Today's quantum chips make errors. Pick the wrong one and the answer is useless</a:t>
             </a:r>
             <a:endParaRPr lang="en-US" sz="1300" dirty="0"/>
           </a:p>
@@ -4900,7 +4909,7 @@
                   <a:schemeClr val="bg1"/>
                 </a:solidFill>
               </a:rPr>
-              <a:t>Companies testing quantum: pharma R&amp;D and finance teams paying for quantum time</a:t>
+              <a:t>Companies trying quantum, like drug makers and banks, who pay for every minute</a:t>
             </a:r>
             <a:endParaRPr lang="en-US" sz="1300" dirty="0"/>
           </a:p>
@@ -4918,7 +4927,7 @@
                   <a:schemeClr val="bg1"/>
                 </a:solidFill>
               </a:rPr>
-              <a:t>Quantum cloud providers (IBM, D-Wave, Amazon) deciding where each job should run</a:t>
+              <a:t>IBM, D-Wave and Amazon, who rent out quantum computers and must decide where each job goes</a:t>
             </a:r>
             <a:endParaRPr lang="en-US" sz="1300" dirty="0"/>
           </a:p>
@@ -4936,7 +4945,7 @@
                   <a:schemeClr val="bg1"/>
                 </a:solidFill>
               </a:rPr>
-              <a:t>Researchers and students with small quantum budgets</a:t>
+              <a:t>Students and researchers with tiny budgets</a:t>
             </a:r>
             <a:endParaRPr lang="en-US" sz="1300" dirty="0"/>
           </a:p>
@@ -5258,7 +5267,7 @@
                   <a:schemeClr val="tx1"/>
                 </a:solidFill>
               </a:rPr>
-              <a:t>10 drug candidates, money for 4</a:t>
+              <a:t>10 possible drugs, money for 4</a:t>
             </a:r>
             <a:endParaRPr lang="en-US" sz="1600" dirty="0"/>
           </a:p>
@@ -5311,7 +5320,7 @@
                   <a:schemeClr val="tx1"/>
                 </a:solidFill>
               </a:rPr>
-              <a:t>payoff = chance of approval × sales − cost</a:t>
+              <a:t>how much money it could make vs. what it costs</a:t>
             </a:r>
             <a:endParaRPr lang="en-US" sz="1400" dirty="0"/>
           </a:p>
@@ -5342,7 +5351,7 @@
                   <a:schemeClr val="tx1"/>
                 </a:solidFill>
               </a:rPr>
-              <a:t>drugs for the same disease succeed or fail together (shared risk)</a:t>
+              <a:t>drugs for the same disease often fail together, which adds risk</a:t>
             </a:r>
             <a:endParaRPr lang="en-US" sz="1400" dirty="0"/>
           </a:p>
@@ -5373,7 +5382,7 @@
                   <a:schemeClr val="tx1"/>
                 </a:solidFill>
               </a:rPr>
-              <a:t>fund exactly 4 (a large penalty for breaking it)</a:t>
+              <a:t>fund exactly 4</a:t>
             </a:r>
             <a:endParaRPr lang="en-US" sz="1400" dirty="0"/>
           </a:p>
@@ -5404,7 +5413,7 @@
                   <a:schemeClr val="tx1"/>
                 </a:solidFill>
               </a:rPr>
-              <a:t>the best payoff for the least risk out of 210 possible groups</a:t>
+              <a:t>the most money for the least risk, out of 210 possible choices</a:t>
             </a:r>
             <a:endParaRPr lang="en-US" sz="1400" dirty="0"/>
           </a:p>
@@ -5440,7 +5449,7 @@
                   <a:schemeClr val="tx2"/>
                 </a:solidFill>
               </a:rPr>
-              <a:t>The same portfolio math investors use for stocks, applied to drugs. Written as a QUBO: one yes/no qubit per drug.</a:t>
+              <a:t>The same math investors use to pick stocks, applied to drugs. Each yes/no choice becomes one qubit.</a:t>
             </a:r>
             <a:endParaRPr lang="en-US" sz="1200" dirty="0"/>
           </a:p>
@@ -5476,7 +5485,7 @@
                   <a:schemeClr val="tx1"/>
                 </a:solidFill>
               </a:rPr>
-              <a:t>The same router is trained on four fields</a:t>
+              <a:t>We also tested three other kinds of decision</a:t>
             </a:r>
             <a:endParaRPr lang="en-US" sz="1500" dirty="0"/>
           </a:p>
@@ -5484,7 +5493,7 @@
       </p:sp>
       <p:sp>
         <p:nvSpPr>
-          <p:cNvPr id="10" name="Finance circle"/>
+          <p:cNvPr id="10" name="Money circle"/>
           <p:cNvSpPr/>
           <p:nvPr/>
         </p:nvSpPr>
@@ -5509,7 +5518,7 @@
       </p:sp>
       <p:pic>
         <p:nvPicPr>
-          <p:cNvPr id="11" name="Finance icon" descr="preencoded.png">    </p:cNvPr>
+          <p:cNvPr id="11" name="Money icon" descr="preencoded.png">    </p:cNvPr>
           <p:cNvPicPr>
             <a:picLocks noChangeAspect="1"/>
           </p:cNvPicPr>
@@ -5561,7 +5570,7 @@
                   <a:schemeClr val="tx1"/>
                 </a:solidFill>
               </a:rPr>
-              <a:t>Finance</a:t>
+              <a:t>Money</a:t>
             </a:r>
             <a:endParaRPr lang="en-US" sz="1400" dirty="0"/>
           </a:p>
@@ -5592,20 +5601,20 @@
               <a:buNone/>
             </a:pPr>
             <a:r>
-              <a:rPr lang="en-US" sz="1200" dirty="0">
+              <a:rPr lang="en-US" sz="1300" dirty="0">
                 <a:solidFill>
                   <a:schemeClr val="tx1"/>
                 </a:solidFill>
               </a:rPr>
-              <a:t>Stock portfolio: real prices of 12 healthcare stocks, 2023-25</a:t>
-            </a:r>
-            <a:endParaRPr lang="en-US" sz="1200" dirty="0"/>
-          </a:p>
-        </p:txBody>
-      </p:sp>
-      <p:sp>
-        <p:nvSpPr>
-          <p:cNvPr id="14" name="Healthcare circle"/>
+              <a:t>Which stocks to buy (real stock prices)</a:t>
+            </a:r>
+            <a:endParaRPr lang="en-US" sz="1300" dirty="0"/>
+          </a:p>
+        </p:txBody>
+      </p:sp>
+      <p:sp>
+        <p:nvSpPr>
+          <p:cNvPr id="14" name="Health circle"/>
           <p:cNvSpPr/>
           <p:nvPr/>
         </p:nvSpPr>
@@ -5630,7 +5639,7 @@
       </p:sp>
       <p:pic>
         <p:nvPicPr>
-          <p:cNvPr id="15" name="Healthcare icon" descr="preencoded.png">    </p:cNvPr>
+          <p:cNvPr id="15" name="Health icon" descr="preencoded.png">    </p:cNvPr>
           <p:cNvPicPr>
             <a:picLocks noChangeAspect="1"/>
           </p:cNvPicPr>
@@ -5682,7 +5691,7 @@
                   <a:schemeClr val="tx1"/>
                 </a:solidFill>
               </a:rPr>
-              <a:t>Healthcare</a:t>
+              <a:t>Health</a:t>
             </a:r>
             <a:endParaRPr lang="en-US" sz="1400" dirty="0"/>
           </a:p>
@@ -5713,20 +5722,20 @@
               <a:buNone/>
             </a:pPr>
             <a:r>
-              <a:rPr lang="en-US" sz="1200" dirty="0">
+              <a:rPr lang="en-US" sz="1300" dirty="0">
                 <a:solidFill>
                   <a:schemeClr val="tx1"/>
                 </a:solidFill>
               </a:rPr>
-              <a:t>Diagnostic tests: real breast-cancer dataset</a:t>
-            </a:r>
-            <a:endParaRPr lang="en-US" sz="1200" dirty="0"/>
-          </a:p>
-        </p:txBody>
-      </p:sp>
-      <p:sp>
-        <p:nvSpPr>
-          <p:cNvPr id="18" name="Finance × healthcare circle"/>
+              <a:t>Which medical tests to order (real patient data)</a:t>
+            </a:r>
+            <a:endParaRPr lang="en-US" sz="1300" dirty="0"/>
+          </a:p>
+        </p:txBody>
+      </p:sp>
+      <p:sp>
+        <p:nvSpPr>
+          <p:cNvPr id="18" name="Money + health circle"/>
           <p:cNvSpPr/>
           <p:nvPr/>
         </p:nvSpPr>
@@ -5751,7 +5760,7 @@
       </p:sp>
       <p:pic>
         <p:nvPicPr>
-          <p:cNvPr id="19" name="Finance × healthcare icon" descr="preencoded.png">    </p:cNvPr>
+          <p:cNvPr id="19" name="Money + health icon" descr="preencoded.png">    </p:cNvPr>
           <p:cNvPicPr>
             <a:picLocks noChangeAspect="1"/>
           </p:cNvPicPr>
@@ -5803,7 +5812,7 @@
                   <a:schemeClr val="tx1"/>
                 </a:solidFill>
               </a:rPr>
-              <a:t>Finance × healthcare</a:t>
+              <a:t>Money + health</a:t>
             </a:r>
             <a:endParaRPr lang="en-US" sz="1400" dirty="0"/>
           </a:p>
@@ -5834,14 +5843,14 @@
               <a:buNone/>
             </a:pPr>
             <a:r>
-              <a:rPr lang="en-US" sz="1200" dirty="0">
+              <a:rPr lang="en-US" sz="1300" dirty="0">
                 <a:solidFill>
                   <a:schemeClr val="tx1"/>
                 </a:solidFill>
               </a:rPr>
-              <a:t>Drug pipeline: industry success rates by trial phase</a:t>
-            </a:r>
-            <a:endParaRPr lang="en-US" sz="1200" dirty="0"/>
+              <a:t>Which drugs to fund (our main example)</a:t>
+            </a:r>
+            <a:endParaRPr lang="en-US" sz="1300" dirty="0"/>
           </a:p>
         </p:txBody>
       </p:sp>
@@ -5955,14 +5964,14 @@
               <a:buNone/>
             </a:pPr>
             <a:r>
-              <a:rPr lang="en-US" sz="1200" dirty="0">
+              <a:rPr lang="en-US" sz="1300" dirty="0">
                 <a:solidFill>
                   <a:schemeClr val="tx1"/>
                 </a:solidFill>
               </a:rPr>
-              <a:t>Split a network, e.g. trial sites between two partners</a:t>
-            </a:r>
-            <a:endParaRPr lang="en-US" sz="1200" dirty="0"/>
+              <a:t>How to split trial sites between two partners</a:t>
+            </a:r>
+            <a:endParaRPr lang="en-US" sz="1300" dirty="0"/>
           </a:p>
         </p:txBody>
       </p:sp>
@@ -6071,7 +6080,7 @@
                 <a:ea typeface="Cambria" pitchFamily="34" charset="-122"/>
                 <a:cs typeface="Cambria" pitchFamily="34" charset="-120"/>
               </a:rPr>
-              <a:t>Two kinds of quantum computer, one IBM chip</a:t>
+              <a:t>Two kinds of quantum computer</a:t>
             </a:r>
             <a:endParaRPr lang="en-US" sz="2800" dirty="0"/>
           </a:p>
@@ -6219,7 +6228,7 @@
                   <a:schemeClr val="tx2"/>
                 </a:solidFill>
               </a:rPr>
-              <a:t>A ball settling into the lowest valley</a:t>
+              <a:t>Like a ball rolling slowly into the lowest valley</a:t>
             </a:r>
             <a:endParaRPr lang="en-US" sz="1200" dirty="0"/>
           </a:p>
@@ -6255,7 +6264,7 @@
                   <a:schemeClr val="tx1"/>
                 </a:solidFill>
               </a:rPr>
-              <a:t>A slow, steady sweep from 'all answers mixed' to 'best answer'. Many steps, almost no tuning. D-Wave builds these; we run a digitized anneal (LR-QAOA) as many small gate steps on IBM.</a:t>
+              <a:t>Many small steps that settle toward the best answer. No tuning needed. D-Wave builds these. IBM doesn't, so we copy the idea with many small steps on IBM's chip.</a:t>
             </a:r>
             <a:endParaRPr lang="en-US" sz="1300" dirty="0"/>
           </a:p>
@@ -6263,7 +6272,7 @@
       </p:sp>
       <p:sp>
         <p:nvSpPr>
-          <p:cNvPr id="9" name="Gate-based (QAOA) card"/>
+          <p:cNvPr id="9" name="Gate-based card"/>
           <p:cNvSpPr/>
           <p:nvPr/>
         </p:nvSpPr>
@@ -6290,7 +6299,7 @@
       </p:sp>
       <p:sp>
         <p:nvSpPr>
-          <p:cNvPr id="10" name="Gate-based (QAOA) circle"/>
+          <p:cNvPr id="10" name="Gate-based circle"/>
           <p:cNvSpPr/>
           <p:nvPr/>
         </p:nvSpPr>
@@ -6315,7 +6324,7 @@
       </p:sp>
       <p:pic>
         <p:nvPicPr>
-          <p:cNvPr id="11" name="Gate-based (QAOA) icon" descr="preencoded.png">    </p:cNvPr>
+          <p:cNvPr id="11" name="Gate-based icon" descr="preencoded.png">    </p:cNvPr>
           <p:cNvPicPr>
             <a:picLocks noChangeAspect="1"/>
           </p:cNvPicPr>
@@ -6367,7 +6376,7 @@
                   <a:schemeClr val="tx1"/>
                 </a:solidFill>
               </a:rPr>
-              <a:t>Gate-based (QAOA)</a:t>
+              <a:t>Gate-based</a:t>
             </a:r>
             <a:endParaRPr lang="en-US" sz="1600" dirty="0"/>
           </a:p>
@@ -6403,7 +6412,7 @@
                   <a:schemeClr val="tx2"/>
                 </a:solidFill>
               </a:rPr>
-              <a:t>A short recipe with tuned dials</a:t>
+              <a:t>Like a short recipe with a few dials</a:t>
             </a:r>
             <a:endParaRPr lang="en-US" sz="1200" dirty="0"/>
           </a:p>
@@ -6439,7 +6448,7 @@
                   <a:schemeClr val="tx1"/>
                 </a:solidFill>
               </a:rPr>
-              <a:t>Mix all answers, link decisions that interact (entanglement), shuffle, measure. Few steps; the dials are tuned on a simulator first. IBM and Google build these.</a:t>
+              <a:t>Only a few steps, but the dials must be tuned first (we tune them on a normal computer). IBM builds these. The recipe we use is called QAOA.</a:t>
             </a:r>
             <a:endParaRPr lang="en-US" sz="1300" dirty="0"/>
           </a:p>
@@ -6534,14 +6543,14 @@
               <a:buChar char="•"/>
             </a:pPr>
             <a:r>
-              <a:rPr lang="en-US" sz="1200" dirty="0">
+              <a:rPr lang="en-US" sz="1300" dirty="0">
                 <a:solidFill>
                   <a:schemeClr val="tx1"/>
                 </a:solidFill>
               </a:rPr>
-              <a:t>Superposition explores every combination at once</a:t>
-            </a:r>
-            <a:endParaRPr lang="en-US" sz="1200" dirty="0"/>
+              <a:t>It can try every combination at the same time</a:t>
+            </a:r>
+            <a:endParaRPr lang="en-US" sz="1300" dirty="0"/>
           </a:p>
           <a:p>
             <a:pPr marL="177800" indent="-177800">
@@ -6549,14 +6558,14 @@
               <a:buChar char="•"/>
             </a:pPr>
             <a:r>
-              <a:rPr lang="en-US" sz="1200" dirty="0">
+              <a:rPr lang="en-US" sz="1300" dirty="0">
                 <a:solidFill>
                   <a:schemeClr val="tx1"/>
                 </a:solidFill>
               </a:rPr>
-              <a:t>Entanglement links decisions that affect each other</a:t>
-            </a:r>
-            <a:endParaRPr lang="en-US" sz="1200" dirty="0"/>
+              <a:t>It can link choices that affect each other</a:t>
+            </a:r>
+            <a:endParaRPr lang="en-US" sz="1300" dirty="0"/>
           </a:p>
           <a:p>
             <a:pPr marL="177800" indent="-177800">
@@ -6564,14 +6573,14 @@
               <a:buChar char="•"/>
             </a:pPr>
             <a:r>
-              <a:rPr lang="en-US" sz="1200" dirty="0">
+              <a:rPr lang="en-US" sz="1300" dirty="0">
                 <a:solidFill>
                   <a:schemeClr val="tx1"/>
                 </a:solidFill>
               </a:rPr>
-              <a:t>Sampling returns many good answers, not just one</a:t>
-            </a:r>
-            <a:endParaRPr lang="en-US" sz="1200" dirty="0"/>
+              <a:t>It gives many good answers to pick from</a:t>
+            </a:r>
+            <a:endParaRPr lang="en-US" sz="1300" dirty="0"/>
           </a:p>
         </p:txBody>
       </p:sp>
@@ -6664,14 +6673,14 @@
               <a:buChar char="•"/>
             </a:pPr>
             <a:r>
-              <a:rPr lang="en-US" sz="1200" dirty="0">
+              <a:rPr lang="en-US" sz="1300" dirty="0">
                 <a:solidFill>
                   <a:schemeClr val="tx1"/>
                 </a:solidFill>
               </a:rPr>
-              <a:t>Every gate adds noise; long circuits drift to random</a:t>
-            </a:r>
-            <a:endParaRPr lang="en-US" sz="1200" dirty="0"/>
+              <a:t>Every step adds a chance of error</a:t>
+            </a:r>
+            <a:endParaRPr lang="en-US" sz="1300" dirty="0"/>
           </a:p>
           <a:p>
             <a:pPr marL="177800" indent="-177800">
@@ -6679,14 +6688,14 @@
               <a:buChar char="•"/>
             </a:pPr>
             <a:r>
-              <a:rPr lang="en-US" sz="1200" dirty="0">
+              <a:rPr lang="en-US" sz="1300" dirty="0">
                 <a:solidFill>
                   <a:schemeClr val="tx1"/>
                 </a:solidFill>
               </a:rPr>
-              <a:t>Our problems use 3-18 qubits; real ones need 50-200</a:t>
-            </a:r>
-            <a:endParaRPr lang="en-US" sz="1200" dirty="0"/>
+              <a:t>Our tests are tiny: 3-18 choices vs. 50-200</a:t>
+            </a:r>
+            <a:endParaRPr lang="en-US" sz="1300" dirty="0"/>
           </a:p>
           <a:p>
             <a:pPr marL="177800" indent="-177800">
@@ -6694,14 +6703,14 @@
               <a:buChar char="•"/>
             </a:pPr>
             <a:r>
-              <a:rPr lang="en-US" sz="1200" dirty="0">
+              <a:rPr lang="en-US" sz="1300" dirty="0">
                 <a:solidFill>
                   <a:schemeClr val="tx1"/>
                 </a:solidFill>
               </a:rPr>
-              <a:t>No proven speedup: a laptop wins at this size</a:t>
-            </a:r>
-            <a:endParaRPr lang="en-US" sz="1200" dirty="0"/>
+              <a:t>A normal laptop still wins today</a:t>
+            </a:r>
+            <a:endParaRPr lang="en-US" sz="1300" dirty="0"/>
           </a:p>
         </p:txBody>
       </p:sp>
@@ -6937,7 +6946,7 @@
         <p:spPr>
           <a:xfrm>
             <a:off x="621792" y="1810512"/>
-            <a:ext cx="2331720" cy="548640"/>
+            <a:ext cx="2377440" cy="548640"/>
           </a:xfrm>
           <a:prstGeom prst="rect">
             <a:avLst/>
@@ -6953,14 +6962,14 @@
               <a:buNone/>
             </a:pPr>
             <a:r>
-              <a:rPr lang="en-US" sz="1400" dirty="0">
+              <a:rPr lang="en-US" sz="1300" dirty="0">
                 <a:solidFill>
                   <a:schemeClr val="tx1"/>
                 </a:solidFill>
               </a:rPr>
-              <a:t>Write the decision as a QUBO score sheet</a:t>
-            </a:r>
-            <a:endParaRPr lang="en-US" sz="1400" dirty="0"/>
+              <a:t>Turn the decision into yes/no choices</a:t>
+            </a:r>
+            <a:endParaRPr lang="en-US" sz="1300" dirty="0"/>
           </a:p>
         </p:txBody>
       </p:sp>
@@ -7085,7 +7094,7 @@
         <p:spPr>
           <a:xfrm>
             <a:off x="3429000" y="1810512"/>
-            <a:ext cx="2331720" cy="548640"/>
+            <a:ext cx="2377440" cy="548640"/>
           </a:xfrm>
           <a:prstGeom prst="rect">
             <a:avLst/>
@@ -7101,14 +7110,14 @@
               <a:buNone/>
             </a:pPr>
             <a:r>
-              <a:rPr lang="en-US" sz="1400" dirty="0">
+              <a:rPr lang="en-US" sz="1300" dirty="0">
                 <a:solidFill>
                   <a:schemeClr val="tx1"/>
                 </a:solidFill>
               </a:rPr>
-              <a:t>Split big problems into pieces of up to 8 decisions</a:t>
-            </a:r>
-            <a:endParaRPr lang="en-US" sz="1400" dirty="0"/>
+              <a:t>Split a big problem into small pieces</a:t>
+            </a:r>
+            <a:endParaRPr lang="en-US" sz="1300" dirty="0"/>
           </a:p>
         </p:txBody>
       </p:sp>
@@ -7218,7 +7227,7 @@
                   <a:schemeClr val="tx1"/>
                 </a:solidFill>
               </a:rPr>
-              <a:t>3. Fingerprint</a:t>
+              <a:t>3. Describe</a:t>
             </a:r>
             <a:endParaRPr lang="en-US" sz="1500" dirty="0"/>
           </a:p>
@@ -7233,7 +7242,7 @@
         <p:spPr>
           <a:xfrm>
             <a:off x="6236208" y="1810512"/>
-            <a:ext cx="2331720" cy="548640"/>
+            <a:ext cx="2377440" cy="548640"/>
           </a:xfrm>
           <a:prstGeom prst="rect">
             <a:avLst/>
@@ -7249,14 +7258,14 @@
               <a:buNone/>
             </a:pPr>
             <a:r>
-              <a:rPr lang="en-US" sz="1400" dirty="0">
+              <a:rPr lang="en-US" sz="1300" dirty="0">
                 <a:solidFill>
                   <a:schemeClr val="tx1"/>
                 </a:solidFill>
               </a:rPr>
-              <a:t>9 numbers: shape, size, and the chip's expected noise</a:t>
-            </a:r>
-            <a:endParaRPr lang="en-US" sz="1400" dirty="0"/>
+              <a:t>How connected is each piece? How many errors would the chip make?</a:t>
+            </a:r>
+            <a:endParaRPr lang="en-US" sz="1300" dirty="0"/>
           </a:p>
         </p:txBody>
       </p:sp>
@@ -7366,7 +7375,7 @@
                   <a:schemeClr val="tx1"/>
                 </a:solidFill>
               </a:rPr>
-              <a:t>4. Route</a:t>
+              <a:t>4. Choose</a:t>
             </a:r>
             <a:endParaRPr lang="en-US" sz="1500" dirty="0"/>
           </a:p>
@@ -7381,7 +7390,7 @@
         <p:spPr>
           <a:xfrm>
             <a:off x="621792" y="3273552"/>
-            <a:ext cx="2331720" cy="548640"/>
+            <a:ext cx="2377440" cy="548640"/>
           </a:xfrm>
           <a:prstGeom prst="rect">
             <a:avLst/>
@@ -7397,14 +7406,14 @@
               <a:buNone/>
             </a:pPr>
             <a:r>
-              <a:rPr lang="en-US" sz="1400" dirty="0">
+              <a:rPr lang="en-US" sz="1300" dirty="0">
                 <a:solidFill>
                   <a:schemeClr val="tx1"/>
                 </a:solidFill>
               </a:rPr>
-              <a:t>An AI picks gate, anneal or laptop for each piece</a:t>
-            </a:r>
-            <a:endParaRPr lang="en-US" sz="1400" dirty="0"/>
+              <a:t>A small AI picks the best computer for each piece</a:t>
+            </a:r>
+            <a:endParaRPr lang="en-US" sz="1300" dirty="0"/>
           </a:p>
         </p:txBody>
       </p:sp>
@@ -7514,7 +7523,7 @@
                   <a:schemeClr val="tx1"/>
                 </a:solidFill>
               </a:rPr>
-              <a:t>5. Solve</a:t>
+              <a:t>5. Reuse</a:t>
             </a:r>
             <a:endParaRPr lang="en-US" sz="1500" dirty="0"/>
           </a:p>
@@ -7529,7 +7538,7 @@
         <p:spPr>
           <a:xfrm>
             <a:off x="3429000" y="3273552"/>
-            <a:ext cx="2331720" cy="548640"/>
+            <a:ext cx="2377440" cy="548640"/>
           </a:xfrm>
           <a:prstGeom prst="rect">
             <a:avLst/>
@@ -7545,14 +7554,14 @@
               <a:buNone/>
             </a:pPr>
             <a:r>
-              <a:rPr lang="en-US" sz="1400" dirty="0">
+              <a:rPr lang="en-US" sz="1300" dirty="0">
                 <a:solidFill>
                   <a:schemeClr val="tx1"/>
                 </a:solidFill>
               </a:rPr>
-              <a:t>Borrow tuned settings from a twin in another industry</a:t>
-            </a:r>
-            <a:endParaRPr lang="en-US" sz="1400" dirty="0"/>
+              <a:t>Copy settings from a similar problem in another industry</a:t>
+            </a:r>
+            <a:endParaRPr lang="en-US" sz="1300" dirty="0"/>
           </a:p>
         </p:txBody>
       </p:sp>
@@ -7662,7 +7671,7 @@
                   <a:schemeClr val="tx1"/>
                 </a:solidFill>
               </a:rPr>
-              <a:t>6. Pack and check</a:t>
+              <a:t>6. Run and check</a:t>
             </a:r>
             <a:endParaRPr lang="en-US" sz="1500" dirty="0"/>
           </a:p>
@@ -7677,7 +7686,7 @@
         <p:spPr>
           <a:xfrm>
             <a:off x="6236208" y="3273552"/>
-            <a:ext cx="2331720" cy="548640"/>
+            <a:ext cx="2377440" cy="548640"/>
           </a:xfrm>
           <a:prstGeom prst="rect">
             <a:avLst/>
@@ -7693,14 +7702,14 @@
               <a:buNone/>
             </a:pPr>
             <a:r>
-              <a:rPr lang="en-US" sz="1400" dirty="0">
+              <a:rPr lang="en-US" sz="1300" dirty="0">
                 <a:solidFill>
                   <a:schemeClr val="tx1"/>
                 </a:solidFill>
               </a:rPr>
-              <a:t>Several problems in one chip job; scored vs. the exact best</a:t>
-            </a:r>
-            <a:endParaRPr lang="en-US" sz="1400" dirty="0"/>
+              <a:t>Run several problems at once; compare with the true best answer</a:t>
+            </a:r>
+            <a:endParaRPr lang="en-US" sz="1300" dirty="0"/>
           </a:p>
         </p:txBody>
       </p:sp>
@@ -7734,7 +7743,7 @@
                   <a:schemeClr val="tx2"/>
                 </a:solidFill>
               </a:rPr>
-              <a:t>The AI is a random forest trained on 60 practice problems from all four fields. Score: 1 = exact best answer, 0 = no better than a random guess.</a:t>
+              <a:t>The AI learned from 60 practice problems solved on a simulator. Score: 1 = the perfect answer, 0 = no better than a random guess.</a:t>
             </a:r>
             <a:endParaRPr lang="en-US" sz="1200" dirty="0"/>
           </a:p>
@@ -7845,7 +7854,7 @@
                 <a:ea typeface="Cambria" pitchFamily="34" charset="-122"/>
                 <a:cs typeface="Cambria" pitchFamily="34" charset="-120"/>
               </a:rPr>
-              <a:t>Under the hood: built with Qiskit</a:t>
+              <a:t>Built with Qiskit, IBM's quantum software</a:t>
             </a:r>
             <a:endParaRPr lang="en-US" sz="2800" dirty="0"/>
           </a:p>
@@ -7908,7 +7917,7 @@
                   <a:schemeClr val="accent1"/>
                 </a:solidFill>
               </a:rPr>
-              <a:t>Circuits</a:t>
+              <a:t>Build</a:t>
             </a:r>
             <a:endParaRPr lang="en-US" sz="1300" dirty="0"/>
           </a:p>
@@ -7944,7 +7953,7 @@
                   <a:schemeClr val="tx1"/>
                 </a:solidFill>
               </a:rPr>
-              <a:t>QUBO → Ising SparsePauliOp → QAOAAnsatz; parameterized and bound</a:t>
+              <a:t>Turns each decision into a quantum recipe (QAOAAnsatz)</a:t>
             </a:r>
             <a:endParaRPr lang="en-US" sz="1200" dirty="0"/>
           </a:p>
@@ -8007,7 +8016,7 @@
                   <a:schemeClr val="accent1"/>
                 </a:solidFill>
               </a:rPr>
-              <a:t>Transpiler</a:t>
+              <a:t>Fit the chip</a:t>
             </a:r>
             <a:endParaRPr lang="en-US" sz="1300" dirty="0"/>
           </a:p>
@@ -8043,7 +8052,7 @@
                   <a:schemeClr val="tx1"/>
                 </a:solidFill>
               </a:rPr>
-              <a:t>Preset pass manager compiles to IBM Torino's real layout and calibration</a:t>
+              <a:t>Rewrites the recipe for IBM's real Torino chip (transpiler)</a:t>
             </a:r>
             <a:endParaRPr lang="en-US" sz="1200" dirty="0"/>
           </a:p>
@@ -8106,7 +8115,7 @@
                   <a:schemeClr val="accent1"/>
                 </a:solidFill>
               </a:rPr>
-              <a:t>Primitives</a:t>
+              <a:t>Run anywhere</a:t>
             </a:r>
             <a:endParaRPr lang="en-US" sz="1300" dirty="0"/>
           </a:p>
@@ -8142,7 +8151,7 @@
                   <a:schemeClr val="tx1"/>
                 </a:solidFill>
               </a:rPr>
-              <a:t>SamplerV2 on Aer, a noisy Torino model, and the real QPU</a:t>
+              <a:t>Same code on a simulator, a copy of the chip, or the real chip</a:t>
             </a:r>
             <a:endParaRPr lang="en-US" sz="1200" dirty="0"/>
           </a:p>
@@ -8205,7 +8214,7 @@
                   <a:schemeClr val="accent1"/>
                 </a:solidFill>
               </a:rPr>
-              <a:t>Optimizer</a:t>
+              <a:t>Tune</a:t>
             </a:r>
             <a:endParaRPr lang="en-US" sz="1300" dirty="0"/>
           </a:p>
@@ -8241,7 +8250,7 @@
                   <a:schemeClr val="tx1"/>
                 </a:solidFill>
               </a:rPr>
-              <a:t>COBYLA tunes gate-QAOA dials; the anneal uses a fixed linear ramp</a:t>
+              <a:t>Adjusts the recipe's dials automatically on a normal computer</a:t>
             </a:r>
             <a:endParaRPr lang="en-US" sz="1200" dirty="0"/>
           </a:p>
@@ -8304,7 +8313,7 @@
                   <a:schemeClr val="accent1"/>
                 </a:solidFill>
               </a:rPr>
-              <a:t>Error mitigation</a:t>
+              <a:t>Fight errors</a:t>
             </a:r>
             <a:endParaRPr lang="en-US" sz="1300" dirty="0"/>
           </a:p>
@@ -8340,7 +8349,7 @@
                   <a:schemeClr val="tx1"/>
                 </a:solidFill>
               </a:rPr>
-              <a:t>Dynamical decoupling, Pauli twirling, zero-noise extrapolation</a:t>
+              <a:t>Three tricks that reduce the chip's mistakes (error mitigation)</a:t>
             </a:r>
             <a:endParaRPr lang="en-US" sz="1200" dirty="0"/>
           </a:p>
@@ -8403,7 +8412,7 @@
                   <a:schemeClr val="accent1"/>
                 </a:solidFill>
               </a:rPr>
-              <a:t>QPU budget</a:t>
+              <a:t>Save time</a:t>
             </a:r>
             <a:endParaRPr lang="en-US" sz="1300" dirty="0"/>
           </a:p>
@@ -8439,7 +8448,7 @@
                   <a:schemeClr val="tx1"/>
                 </a:solidFill>
               </a:rPr>
-              <a:t>Many circuits batched into one job: about 3 of our 10 minutes</a:t>
+              <a:t>Sends many recipes in one trip: about 3 of our 10 minutes</a:t>
             </a:r>
             <a:endParaRPr lang="en-US" sz="1200" dirty="0"/>
           </a:p>
@@ -8524,7 +8533,7 @@
         <p:spPr>
           <a:xfrm>
             <a:off x="5760720" y="1508760"/>
-            <a:ext cx="2788920" cy="1463040"/>
+            <a:ext cx="2788920" cy="1508760"/>
           </a:xfrm>
           <a:prstGeom prst="rect">
             <a:avLst/>
@@ -8548,7 +8557,7 @@
                   <a:schemeClr val="bg1"/>
                 </a:solidFill>
               </a:rPr>
-              <a:t>A sign error made every circuit search for the worst answer.</a:t>
+              <a:t>A plus/minus mix-up made our recipe hunt for the worst answer.</a:t>
             </a:r>
             <a:endParaRPr lang="en-US" sz="1200" dirty="0"/>
           </a:p>
@@ -8599,7 +8608,7 @@
                   <a:schemeClr val="bg1"/>
                 </a:solidFill>
               </a:rPr>
-              <a:t>Lesson: always score against a known best answer.</a:t>
+              <a:t>Lesson: always check against a known best answer.</a:t>
             </a:r>
             <a:endParaRPr lang="en-US" sz="1200" dirty="0"/>
           </a:p>
@@ -8662,7 +8671,7 @@
                   <a:schemeClr val="tx1"/>
                 </a:solidFill>
               </a:rPr>
-              <a:t>Reproducible</a:t>
+              <a:t>Anyone can rerun it</a:t>
             </a:r>
             <a:endParaRPr lang="en-US" sz="1400" dirty="0"/>
           </a:p>
@@ -8698,7 +8707,7 @@
                   <a:schemeClr val="tx1"/>
                 </a:solidFill>
               </a:rPr>
-              <a:t>One notebook, Runtime → Run all. Every hardware cell was dry-run on a fake IBM Torino first.</a:t>
+              <a:t>One notebook: press Run all. We tested the real-chip code on a fake copy of the chip first.</a:t>
             </a:r>
             <a:endParaRPr lang="en-US" sz="1200" dirty="0"/>
           </a:p>
@@ -8809,7 +8818,7 @@
                 <a:ea typeface="Cambria" pitchFamily="34" charset="-122"/>
                 <a:cs typeface="Cambria" pitchFamily="34" charset="-120"/>
               </a:rPr>
-              <a:t>Dense pieces → gate-based; sparse → annealing</a:t>
+              <a:t>Each piece of a problem suits a different computer</a:t>
             </a:r>
             <a:endParaRPr lang="en-US" sz="2800" dirty="0"/>
           </a:p>
@@ -8840,7 +8849,7 @@
         <p:spPr>
           <a:xfrm>
             <a:off x="457200" y="4160520"/>
-            <a:ext cx="4937760" cy="274320"/>
+            <a:ext cx="4937760" cy="365760"/>
           </a:xfrm>
           <a:prstGeom prst="rect">
             <a:avLst/>
@@ -8861,7 +8870,7 @@
                   <a:schemeClr val="accent3"/>
                 </a:solidFill>
               </a:rPr>
-              <a:t>Drug funding: 8 qubits, dense · Trial sites A: 7 qubits, sparse · Trial sites B: 3 qubits</a:t>
+              <a:t>Drug funding: every choice affects every other. Trial sites: each site affects only a few others.</a:t>
             </a:r>
             <a:endParaRPr lang="en-US" sz="1000" dirty="0"/>
           </a:p>
@@ -8924,7 +8933,7 @@
                   <a:schemeClr val="tx1"/>
                 </a:solidFill>
               </a:rPr>
-              <a:t>Average score by strategy</a:t>
+              <a:t>Mixing both beats either one</a:t>
             </a:r>
             <a:endParaRPr lang="en-US" sz="1300" dirty="0"/>
           </a:p>
@@ -8960,7 +8969,7 @@
                   <a:schemeClr val="tx1"/>
                 </a:solidFill>
               </a:rPr>
-              <a:t>All gate-based</a:t>
+              <a:t>Gate-based only</a:t>
             </a:r>
             <a:endParaRPr lang="en-US" sz="1300" dirty="0"/>
           </a:p>
@@ -9057,7 +9066,7 @@
                   <a:schemeClr val="tx1"/>
                 </a:solidFill>
               </a:rPr>
-              <a:t>All annealing</a:t>
+              <a:t>Annealing only</a:t>
             </a:r>
             <a:endParaRPr lang="en-US" sz="1300" dirty="0"/>
           </a:p>
@@ -9154,7 +9163,7 @@
                   <a:schemeClr val="tx1"/>
                 </a:solidFill>
               </a:rPr>
-              <a:t>Router's mix</a:t>
+              <a:t>Q-Router's mix</a:t>
             </a:r>
             <a:endParaRPr lang="en-US" sz="1300" dirty="0"/>
           </a:p>
@@ -9285,7 +9294,7 @@
                   <a:schemeClr val="bg1"/>
                 </a:solidFill>
               </a:rPr>
-              <a:t>Across 60 problems, annealing wins</a:t>
+              <a:t>60 practice problems: annealing won</a:t>
             </a:r>
             <a:endParaRPr lang="en-US" sz="1300" dirty="0"/>
           </a:p>
@@ -9324,7 +9333,7 @@
                   <a:schemeClr val="bg1"/>
                 </a:solidFill>
               </a:rPr>
-              <a:t>Finance (stocks): 0 of 11</a:t>
+              <a:t>Stocks: 0 of 11</a:t>
             </a:r>
             <a:endParaRPr lang="en-US" sz="1200" dirty="0"/>
           </a:p>
@@ -9341,7 +9350,7 @@
                   <a:schemeClr val="bg1"/>
                 </a:solidFill>
               </a:rPr>
-              <a:t>Finance × healthcare (drugs): 2 of 16</a:t>
+              <a:t>Drugs: 2 of 16</a:t>
             </a:r>
             <a:endParaRPr lang="en-US" sz="1200" dirty="0"/>
           </a:p>
@@ -9358,7 +9367,7 @@
                   <a:schemeClr val="bg1"/>
                 </a:solidFill>
               </a:rPr>
-              <a:t>Healthcare (tests): 4 of 15</a:t>
+              <a:t>Medical tests: 4 of 15</a:t>
             </a:r>
             <a:endParaRPr lang="en-US" sz="1200" dirty="0"/>
           </a:p>
@@ -9486,7 +9495,7 @@
                 <a:ea typeface="Cambria" pitchFamily="34" charset="-122"/>
                 <a:cs typeface="Cambria" pitchFamily="34" charset="-120"/>
               </a:rPr>
-              <a:t>Patterns across industries save quantum time</a:t>
+              <a:t>Learning across industries saves quantum time</a:t>
             </a:r>
             <a:endParaRPr lang="en-US" sz="2800" dirty="0"/>
           </a:p>
@@ -9538,7 +9547,7 @@
                   <a:schemeClr val="tx2"/>
                 </a:solidFill>
               </a:rPr>
-              <a:t>Twin beats random donor by 0.023 ± 0.010 (standard error), on 65% of problems</a:t>
+              <a:t>Copying from a similar problem beats copying from a random one on 65% of problems</a:t>
             </a:r>
             <a:endParaRPr lang="en-US" sz="1100" dirty="0"/>
           </a:p>
@@ -9625,8 +9634,8 @@
         </p:nvSpPr>
         <p:spPr>
           <a:xfrm>
-            <a:off x="6537960" y="1188720"/>
-            <a:ext cx="2011680" cy="685800"/>
+            <a:off x="6537960" y="1143000"/>
+            <a:ext cx="2057400" cy="777240"/>
           </a:xfrm>
           <a:prstGeom prst="rect">
             <a:avLst/>
@@ -9642,14 +9651,14 @@
               <a:buNone/>
             </a:pPr>
             <a:r>
-              <a:rPr lang="en-US" sz="1300" b="1" dirty="0">
+              <a:rPr lang="en-US" sz="1200" b="1" dirty="0">
                 <a:solidFill>
                   <a:schemeClr val="bg1"/>
                 </a:solidFill>
               </a:rPr>
-              <a:t>fewer quantum shots with one tune, one job</a:t>
-            </a:r>
-            <a:endParaRPr lang="en-US" sz="1300" dirty="0"/>
+              <a:t>less quantum time when similar problems share settings and run together</a:t>
+            </a:r>
+            <a:endParaRPr lang="en-US" sz="1200" dirty="0"/>
           </a:p>
         </p:txBody>
       </p:sp>
@@ -9683,7 +9692,7 @@
                   <a:schemeClr val="bg1"/>
                 </a:solidFill>
               </a:rPr>
-              <a:t>4 problems, 4 industries: tunings 4 → 2, chip jobs 4 → 1, quality kept 96% (0.524 → 0.504)</a:t>
+              <a:t>4 problems from 4 industries: 1 trip to the chip instead of 4, keeping 96% of the quality</a:t>
             </a:r>
             <a:endParaRPr lang="en-US" sz="1200" dirty="0"/>
           </a:p>
@@ -9785,7 +9794,7 @@
                   <a:schemeClr val="tx1"/>
                 </a:solidFill>
               </a:rPr>
-              <a:t>score when entanglement is switched off</a:t>
+              <a:t>score when we cut the links between qubits</a:t>
             </a:r>
             <a:endParaRPr lang="en-US" sz="1100" dirty="0"/>
           </a:p>
@@ -9887,7 +9896,7 @@
                   <a:schemeClr val="tx1"/>
                 </a:solidFill>
               </a:rPr>
-              <a:t>classical laptop on every problem: no quantum advantage</a:t>
+              <a:t>a normal laptop's score: it still wins every time</a:t>
             </a:r>
             <a:endParaRPr lang="en-US" sz="1100" dirty="0"/>
           </a:p>
@@ -9998,7 +10007,7 @@
                 <a:ea typeface="Cambria" pitchFamily="34" charset="-122"/>
                 <a:cs typeface="Cambria" pitchFamily="34" charset="-120"/>
               </a:rPr>
-              <a:t>Real IBM hardware and noise analysis</a:t>
+              <a:t>Testing on a real IBM quantum chip</a:t>
             </a:r>
             <a:endParaRPr lang="en-US" sz="2800" dirty="0"/>
           </a:p>
@@ -10034,7 +10043,7 @@
                   <a:schemeClr val="tx2"/>
                 </a:solidFill>
               </a:rPr>
-              <a:t>Flagship drug problem (8 drugs, fund 3) on a real IBM quantum processor · score 1 = best, 0 = random</a:t>
+              <a:t>Drug problem (8 drugs, fund 3) on a real IBM quantum chip · score: 1 = perfect, 0 = random guess</a:t>
             </a:r>
             <a:endParaRPr lang="en-US" sz="1200" dirty="0"/>
           </a:p>
@@ -10137,7 +10146,7 @@
                             <a:srgbClr val="FFFFFF"/>
                           </a:solidFill>
                         </a:rPr>
-                        <a:t>Perfect simulator</a:t>
+                        <a:t>Perfect (no errors)</a:t>
                       </a:r>
                       <a:endParaRPr lang="en-US" sz="1200" dirty="0"/>
                     </a:p>
@@ -10198,7 +10207,7 @@
                             <a:srgbClr val="FFFFFF"/>
                           </a:solidFill>
                         </a:rPr>
-                        <a:t>Noisy chip model</a:t>
+                        <a:t>Copy of chip (with errors)</a:t>
                       </a:r>
                       <a:endParaRPr lang="en-US" sz="1200" dirty="0"/>
                     </a:p>
@@ -10259,7 +10268,7 @@
                             <a:srgbClr val="FFFFFF"/>
                           </a:solidFill>
                         </a:rPr>
-                        <a:t>Real QPU raw</a:t>
+                        <a:t>Real chip</a:t>
                       </a:r>
                       <a:endParaRPr lang="en-US" sz="1200" dirty="0"/>
                     </a:p>
@@ -10320,7 +10329,7 @@
                             <a:srgbClr val="FFFFFF"/>
                           </a:solidFill>
                         </a:rPr>
-                        <a:t>QPU + mitigation</a:t>
+                        <a:t>Real chip + fixes</a:t>
                       </a:r>
                       <a:endParaRPr lang="en-US" sz="1200" dirty="0"/>
                     </a:p>
@@ -10383,7 +10392,7 @@
                             <a:srgbClr val="5B4FD1"/>
                           </a:solidFill>
                         </a:rPr>
-                        <a:t>Gate-based QAOA</a:t>
+                        <a:t>Gate-based</a:t>
                       </a:r>
                       <a:endParaRPr lang="en-US" sz="1200" dirty="0"/>
                     </a:p>
@@ -10690,7 +10699,7 @@
                             <a:srgbClr val="0E9384"/>
                           </a:solidFill>
                         </a:rPr>
-                        <a:t>Digital anneal</a:t>
+                        <a:t>Annealing</a:t>
                       </a:r>
                       <a:endParaRPr lang="en-US" sz="1200" dirty="0"/>
                     </a:p>
@@ -10997,7 +11006,7 @@
                             <a:srgbClr val="667085"/>
                           </a:solidFill>
                         </a:rPr>
-                        <a:t>Classical (laptop)</a:t>
+                        <a:t>Normal laptop</a:t>
                       </a:r>
                       <a:endParaRPr lang="en-US" sz="1200" dirty="0"/>
                     </a:p>
@@ -11323,7 +11332,7 @@
                   <a:schemeClr val="tx1"/>
                 </a:solidFill>
               </a:rPr>
-              <a:t>Hardware experiments (about 3 of our 10 QPU minutes)</a:t>
+              <a:t>Real-chip tests (about 3 of our 10 quantum minutes)</a:t>
             </a:r>
             <a:endParaRPr lang="en-US" sz="1300" dirty="0"/>
           </a:p>
@@ -11331,7 +11340,7 @@
       </p:sp>
       <p:sp>
         <p:nvSpPr>
-          <p:cNvPr id="6" name="HW run 9"/>
+          <p:cNvPr id="6" name="HW run 0"/>
           <p:cNvSpPr/>
           <p:nvPr/>
         </p:nvSpPr>
@@ -11364,7 +11373,7 @@
         </p:nvSpPr>
         <p:spPr>
           <a:xfrm>
-            <a:off x="566928" y="3419856"/>
+            <a:off x="566928" y="3438144"/>
             <a:ext cx="1097280" cy="274320"/>
           </a:xfrm>
           <a:prstGeom prst="rect">
@@ -11386,7 +11395,7 @@
                   <a:schemeClr val="accent1"/>
                 </a:solidFill>
               </a:rPr>
-              <a:t>§9</a:t>
+              <a:t>Test 1</a:t>
             </a:r>
             <a:endParaRPr lang="en-US" sz="1400" dirty="0"/>
           </a:p>
@@ -11400,8 +11409,8 @@
         </p:nvSpPr>
         <p:spPr>
           <a:xfrm>
-            <a:off x="566928" y="3703320"/>
-            <a:ext cx="1115568" cy="475488"/>
+            <a:off x="566928" y="3730752"/>
+            <a:ext cx="1115568" cy="640080"/>
           </a:xfrm>
           <a:prstGeom prst="rect">
             <a:avLst/>
@@ -11417,56 +11426,20 @@
               <a:buNone/>
             </a:pPr>
             <a:r>
-              <a:rPr lang="en-US" sz="1100" dirty="0">
+              <a:rPr lang="en-US" sz="1200" dirty="0">
                 <a:solidFill>
                   <a:schemeClr val="tx1"/>
                 </a:solidFill>
               </a:rPr>
-              <a:t>Both styles, raw vs. mitigated</a:t>
-            </a:r>
-            <a:endParaRPr lang="en-US" sz="1100" dirty="0"/>
-          </a:p>
-        </p:txBody>
-      </p:sp>
-      <p:sp>
-        <p:nvSpPr>
-          <p:cNvPr id="9" name="Text 6"/>
-          <p:cNvSpPr txBox="1"/>
-          <p:nvPr/>
-        </p:nvSpPr>
-        <p:spPr>
-          <a:xfrm>
-            <a:off x="566928" y="4160520"/>
-            <a:ext cx="1097280" cy="228600"/>
-          </a:xfrm>
-          <a:prstGeom prst="rect">
-            <a:avLst/>
-          </a:prstGeom>
-          <a:noFill/>
-          <a:ln/>
-        </p:spPr>
-        <p:txBody>
-          <a:bodyPr wrap="square" lIns="0" tIns="0" rIns="0" bIns="0" rtlCol="0" anchor="t"/>
-          <a:lstStyle/>
-          <a:p>
-            <a:pPr indent="0" marL="0">
-              <a:buNone/>
-            </a:pPr>
-            <a:r>
-              <a:rPr lang="en-US" sz="1000" dirty="0">
-                <a:solidFill>
-                  <a:schemeClr val="accent3"/>
-                </a:solidFill>
-              </a:rPr>
-              <a:t>4 jobs</a:t>
-            </a:r>
-            <a:endParaRPr lang="en-US" sz="1000" dirty="0"/>
-          </a:p>
-        </p:txBody>
-      </p:sp>
-      <p:sp>
-        <p:nvSpPr>
-          <p:cNvPr id="10" name="HW run 9b"/>
+              <a:t>Both kinds, with and without fixes</a:t>
+            </a:r>
+            <a:endParaRPr lang="en-US" sz="1200" dirty="0"/>
+          </a:p>
+        </p:txBody>
+      </p:sp>
+      <p:sp>
+        <p:nvSpPr>
+          <p:cNvPr id="9" name="HW run 1"/>
           <p:cNvSpPr/>
           <p:nvPr/>
         </p:nvSpPr>
@@ -11493,14 +11466,50 @@
       </p:sp>
       <p:sp>
         <p:nvSpPr>
+          <p:cNvPr id="10" name="Text 7"/>
+          <p:cNvSpPr txBox="1"/>
+          <p:nvPr/>
+        </p:nvSpPr>
+        <p:spPr>
+          <a:xfrm>
+            <a:off x="1956816" y="3438144"/>
+            <a:ext cx="1097280" cy="274320"/>
+          </a:xfrm>
+          <a:prstGeom prst="rect">
+            <a:avLst/>
+          </a:prstGeom>
+          <a:noFill/>
+          <a:ln/>
+        </p:spPr>
+        <p:txBody>
+          <a:bodyPr wrap="square" lIns="0" tIns="0" rIns="0" bIns="0" rtlCol="0" anchor="t"/>
+          <a:lstStyle/>
+          <a:p>
+            <a:pPr indent="0" marL="0">
+              <a:buNone/>
+            </a:pPr>
+            <a:r>
+              <a:rPr lang="en-US" sz="1400" b="1" dirty="0">
+                <a:solidFill>
+                  <a:schemeClr val="accent1"/>
+                </a:solidFill>
+              </a:rPr>
+              <a:t>Test 2</a:t>
+            </a:r>
+            <a:endParaRPr lang="en-US" sz="1400" dirty="0"/>
+          </a:p>
+        </p:txBody>
+      </p:sp>
+      <p:sp>
+        <p:nvSpPr>
           <p:cNvPr id="11" name="Text 8"/>
           <p:cNvSpPr txBox="1"/>
           <p:nvPr/>
         </p:nvSpPr>
         <p:spPr>
           <a:xfrm>
-            <a:off x="1956816" y="3419856"/>
-            <a:ext cx="1097280" cy="274320"/>
+            <a:off x="1956816" y="3730752"/>
+            <a:ext cx="1115568" cy="640080"/>
           </a:xfrm>
           <a:prstGeom prst="rect">
             <a:avLst/>
@@ -11516,92 +11525,20 @@
               <a:buNone/>
             </a:pPr>
             <a:r>
-              <a:rPr lang="en-US" sz="1400" b="1" dirty="0">
-                <a:solidFill>
-                  <a:schemeClr val="accent1"/>
-                </a:solidFill>
-              </a:rPr>
-              <a:t>§9b</a:t>
-            </a:r>
-            <a:endParaRPr lang="en-US" sz="1400" dirty="0"/>
-          </a:p>
-        </p:txBody>
-      </p:sp>
-      <p:sp>
-        <p:nvSpPr>
-          <p:cNvPr id="12" name="Text 9"/>
-          <p:cNvSpPr txBox="1"/>
-          <p:nvPr/>
-        </p:nvSpPr>
-        <p:spPr>
-          <a:xfrm>
-            <a:off x="1956816" y="3703320"/>
-            <a:ext cx="1115568" cy="475488"/>
-          </a:xfrm>
-          <a:prstGeom prst="rect">
-            <a:avLst/>
-          </a:prstGeom>
-          <a:noFill/>
-          <a:ln/>
-        </p:spPr>
-        <p:txBody>
-          <a:bodyPr wrap="square" lIns="0" tIns="0" rIns="0" bIns="0" rtlCol="0" anchor="t"/>
-          <a:lstStyle/>
-          <a:p>
-            <a:pPr indent="0" marL="0">
-              <a:buNone/>
-            </a:pPr>
-            <a:r>
-              <a:rPr lang="en-US" sz="1100" dirty="0">
+              <a:rPr lang="en-US" sz="1200" dirty="0">
                 <a:solidFill>
                   <a:schemeClr val="tx1"/>
                 </a:solidFill>
               </a:rPr>
-              <a:t>Break-down pieces, both styles</a:t>
-            </a:r>
-            <a:endParaRPr lang="en-US" sz="1100" dirty="0"/>
-          </a:p>
-        </p:txBody>
-      </p:sp>
-      <p:sp>
-        <p:nvSpPr>
-          <p:cNvPr id="13" name="Text 10"/>
-          <p:cNvSpPr txBox="1"/>
-          <p:nvPr/>
-        </p:nvSpPr>
-        <p:spPr>
-          <a:xfrm>
-            <a:off x="1956816" y="4160520"/>
-            <a:ext cx="1097280" cy="228600"/>
-          </a:xfrm>
-          <a:prstGeom prst="rect">
-            <a:avLst/>
-          </a:prstGeom>
-          <a:noFill/>
-          <a:ln/>
-        </p:spPr>
-        <p:txBody>
-          <a:bodyPr wrap="square" lIns="0" tIns="0" rIns="0" bIns="0" rtlCol="0" anchor="t"/>
-          <a:lstStyle/>
-          <a:p>
-            <a:pPr indent="0" marL="0">
-              <a:buNone/>
-            </a:pPr>
-            <a:r>
-              <a:rPr lang="en-US" sz="1000" dirty="0">
-                <a:solidFill>
-                  <a:schemeClr val="accent3"/>
-                </a:solidFill>
-              </a:rPr>
-              <a:t>1 job</a:t>
-            </a:r>
-            <a:endParaRPr lang="en-US" sz="1000" dirty="0"/>
-          </a:p>
-        </p:txBody>
-      </p:sp>
-      <p:sp>
-        <p:nvSpPr>
-          <p:cNvPr id="14" name="HW run 11"/>
+              <a:t>The 3 pieces, both kinds</a:t>
+            </a:r>
+            <a:endParaRPr lang="en-US" sz="1200" dirty="0"/>
+          </a:p>
+        </p:txBody>
+      </p:sp>
+      <p:sp>
+        <p:nvSpPr>
+          <p:cNvPr id="12" name="HW run 2"/>
           <p:cNvSpPr/>
           <p:nvPr/>
         </p:nvSpPr>
@@ -11628,13 +11565,13 @@
       </p:sp>
       <p:sp>
         <p:nvSpPr>
-          <p:cNvPr id="15" name="Text 12"/>
+          <p:cNvPr id="13" name="Text 10"/>
           <p:cNvSpPr txBox="1"/>
           <p:nvPr/>
         </p:nvSpPr>
         <p:spPr>
           <a:xfrm>
-            <a:off x="3346704" y="3419856"/>
+            <a:off x="3346704" y="3438144"/>
             <a:ext cx="1097280" cy="274320"/>
           </a:xfrm>
           <a:prstGeom prst="rect">
@@ -11656,7 +11593,7 @@
                   <a:schemeClr val="accent1"/>
                 </a:solidFill>
               </a:rPr>
-              <a:t>§11</a:t>
+              <a:t>Test 3</a:t>
             </a:r>
             <a:endParaRPr lang="en-US" sz="1400" dirty="0"/>
           </a:p>
@@ -11664,14 +11601,14 @@
       </p:sp>
       <p:sp>
         <p:nvSpPr>
-          <p:cNvPr id="16" name="Text 13"/>
+          <p:cNvPr id="14" name="Text 11"/>
           <p:cNvSpPr txBox="1"/>
           <p:nvPr/>
         </p:nvSpPr>
         <p:spPr>
           <a:xfrm>
-            <a:off x="3346704" y="3703320"/>
-            <a:ext cx="1115568" cy="475488"/>
+            <a:off x="3346704" y="3730752"/>
+            <a:ext cx="1115568" cy="640080"/>
           </a:xfrm>
           <a:prstGeom prst="rect">
             <a:avLst/>
@@ -11687,56 +11624,20 @@
               <a:buNone/>
             </a:pPr>
             <a:r>
-              <a:rPr lang="en-US" sz="1100" dirty="0">
+              <a:rPr lang="en-US" sz="1200" dirty="0">
                 <a:solidFill>
                   <a:schemeClr val="tx1"/>
                 </a:solidFill>
               </a:rPr>
-              <a:t>3 industries packed on one chip</a:t>
-            </a:r>
-            <a:endParaRPr lang="en-US" sz="1100" dirty="0"/>
-          </a:p>
-        </p:txBody>
-      </p:sp>
-      <p:sp>
-        <p:nvSpPr>
-          <p:cNvPr id="17" name="Text 14"/>
-          <p:cNvSpPr txBox="1"/>
-          <p:nvPr/>
-        </p:nvSpPr>
-        <p:spPr>
-          <a:xfrm>
-            <a:off x="3346704" y="4160520"/>
-            <a:ext cx="1097280" cy="228600"/>
-          </a:xfrm>
-          <a:prstGeom prst="rect">
-            <a:avLst/>
-          </a:prstGeom>
-          <a:noFill/>
-          <a:ln/>
-        </p:spPr>
-        <p:txBody>
-          <a:bodyPr wrap="square" lIns="0" tIns="0" rIns="0" bIns="0" rtlCol="0" anchor="t"/>
-          <a:lstStyle/>
-          <a:p>
-            <a:pPr indent="0" marL="0">
-              <a:buNone/>
-            </a:pPr>
-            <a:r>
-              <a:rPr lang="en-US" sz="1000" dirty="0">
-                <a:solidFill>
-                  <a:schemeClr val="accent3"/>
-                </a:solidFill>
-              </a:rPr>
-              <a:t>1 job</a:t>
-            </a:r>
-            <a:endParaRPr lang="en-US" sz="1000" dirty="0"/>
-          </a:p>
-        </p:txBody>
-      </p:sp>
-      <p:sp>
-        <p:nvSpPr>
-          <p:cNvPr id="18" name="HW run 11b"/>
+              <a:t>3 industries on one chip</a:t>
+            </a:r>
+            <a:endParaRPr lang="en-US" sz="1200" dirty="0"/>
+          </a:p>
+        </p:txBody>
+      </p:sp>
+      <p:sp>
+        <p:nvSpPr>
+          <p:cNvPr id="15" name="HW run 3"/>
           <p:cNvSpPr/>
           <p:nvPr/>
         </p:nvSpPr>
@@ -11763,13 +11664,13 @@
       </p:sp>
       <p:sp>
         <p:nvSpPr>
-          <p:cNvPr id="19" name="Text 16"/>
+          <p:cNvPr id="16" name="Text 13"/>
           <p:cNvSpPr txBox="1"/>
           <p:nvPr/>
         </p:nvSpPr>
         <p:spPr>
           <a:xfrm>
-            <a:off x="4736592" y="3419856"/>
+            <a:off x="4736592" y="3438144"/>
             <a:ext cx="1097280" cy="274320"/>
           </a:xfrm>
           <a:prstGeom prst="rect">
@@ -11791,7 +11692,7 @@
                   <a:schemeClr val="accent1"/>
                 </a:solidFill>
               </a:rPr>
-              <a:t>§11b</a:t>
+              <a:t>Test 4</a:t>
             </a:r>
             <a:endParaRPr lang="en-US" sz="1400" dirty="0"/>
           </a:p>
@@ -11799,14 +11700,14 @@
       </p:sp>
       <p:sp>
         <p:nvSpPr>
-          <p:cNvPr id="20" name="Text 17"/>
+          <p:cNvPr id="17" name="Text 14"/>
           <p:cNvSpPr txBox="1"/>
           <p:nvPr/>
         </p:nvSpPr>
         <p:spPr>
           <a:xfrm>
-            <a:off x="4736592" y="3703320"/>
-            <a:ext cx="1115568" cy="475488"/>
+            <a:off x="4736592" y="3730752"/>
+            <a:ext cx="1115568" cy="640080"/>
           </a:xfrm>
           <a:prstGeom prst="rect">
             <a:avLst/>
@@ -11822,56 +11723,20 @@
               <a:buNone/>
             </a:pPr>
             <a:r>
-              <a:rPr lang="en-US" sz="1100" dirty="0">
+              <a:rPr lang="en-US" sz="1200" dirty="0">
                 <a:solidFill>
                   <a:schemeClr val="tx1"/>
                 </a:solidFill>
               </a:rPr>
-              <a:t>One tune, one job</a:t>
-            </a:r>
-            <a:endParaRPr lang="en-US" sz="1100" dirty="0"/>
-          </a:p>
-        </p:txBody>
-      </p:sp>
-      <p:sp>
-        <p:nvSpPr>
-          <p:cNvPr id="21" name="Text 18"/>
-          <p:cNvSpPr txBox="1"/>
-          <p:nvPr/>
-        </p:nvSpPr>
-        <p:spPr>
-          <a:xfrm>
-            <a:off x="4736592" y="4160520"/>
-            <a:ext cx="1097280" cy="228600"/>
-          </a:xfrm>
-          <a:prstGeom prst="rect">
-            <a:avLst/>
-          </a:prstGeom>
-          <a:noFill/>
-          <a:ln/>
-        </p:spPr>
-        <p:txBody>
-          <a:bodyPr wrap="square" lIns="0" tIns="0" rIns="0" bIns="0" rtlCol="0" anchor="t"/>
-          <a:lstStyle/>
-          <a:p>
-            <a:pPr indent="0" marL="0">
-              <a:buNone/>
-            </a:pPr>
-            <a:r>
-              <a:rPr lang="en-US" sz="1000" dirty="0">
-                <a:solidFill>
-                  <a:schemeClr val="accent3"/>
-                </a:solidFill>
-              </a:rPr>
-              <a:t>1 job</a:t>
-            </a:r>
-            <a:endParaRPr lang="en-US" sz="1000" dirty="0"/>
-          </a:p>
-        </p:txBody>
-      </p:sp>
-      <p:sp>
-        <p:nvSpPr>
-          <p:cNvPr id="22" name="Noise card"/>
+              <a:t>Shared settings, one trip</a:t>
+            </a:r>
+            <a:endParaRPr lang="en-US" sz="1200" dirty="0"/>
+          </a:p>
+        </p:txBody>
+      </p:sp>
+      <p:sp>
+        <p:nvSpPr>
+          <p:cNvPr id="18" name="Noise card"/>
           <p:cNvSpPr/>
           <p:nvPr/>
         </p:nvSpPr>
@@ -11905,7 +11770,7 @@
       </p:sp>
       <p:sp>
         <p:nvSpPr>
-          <p:cNvPr id="23" name="Text 20"/>
+          <p:cNvPr id="19" name="Text 16"/>
           <p:cNvSpPr txBox="1"/>
           <p:nvPr/>
         </p:nvSpPr>
@@ -11933,7 +11798,7 @@
                   <a:schemeClr val="bg1"/>
                 </a:solidFill>
               </a:rPr>
-              <a:t>Noise, measured</a:t>
+              <a:t>What errors cost us</a:t>
             </a:r>
             <a:endParaRPr lang="en-US" sz="1400" dirty="0"/>
           </a:p>
@@ -11941,7 +11806,7 @@
       </p:sp>
       <p:sp>
         <p:nvSpPr>
-          <p:cNvPr id="24" name="Text 21"/>
+          <p:cNvPr id="20" name="Text 17"/>
           <p:cNvSpPr txBox="1"/>
           <p:nvPr/>
         </p:nvSpPr>
@@ -11973,7 +11838,7 @@
                   <a:schemeClr val="bg1"/>
                 </a:solidFill>
               </a:rPr>
-              <a:t>Zero-noise extrapolation won back ~25% of the quality noise destroyed</a:t>
+              <a:t>Annealing is best with no errors, but takes 7× more risky steps, so it falls behind on a real chip</a:t>
             </a:r>
             <a:endParaRPr lang="en-US" sz="1200" dirty="0"/>
           </a:p>
@@ -11991,7 +11856,7 @@
                   <a:schemeClr val="bg1"/>
                 </a:solidFill>
               </a:rPr>
-              <a:t>The anneal wins on a perfect simulator but needs 688 entangling gates vs. 104, so noise drags it down</a:t>
+              <a:t>An error-cancelling trick won back about 25% of the lost quality</a:t>
             </a:r>
             <a:endParaRPr lang="en-US" sz="1200" dirty="0"/>
           </a:p>
@@ -12009,25 +11874,7 @@
                   <a:schemeClr val="bg1"/>
                 </a:solidFill>
               </a:rPr>
-              <a:t>Crosstalk from packing 3 problems: ~0.01</a:t>
-            </a:r>
-            <a:endParaRPr lang="en-US" sz="1200" dirty="0"/>
-          </a:p>
-          <a:p>
-            <a:pPr marL="177800" indent="-177800">
-              <a:spcAft>
-                <a:spcPts val="600"/>
-              </a:spcAft>
-              <a:buSzPct val="100000"/>
-              <a:buChar char="•"/>
-            </a:pPr>
-            <a:r>
-              <a:rPr lang="en-US" sz="1200" dirty="0">
-                <a:solidFill>
-                  <a:schemeClr val="bg1"/>
-                </a:solidFill>
-              </a:rPr>
-              <a:t>On hardware: dynamical decoupling + Pauli twirling, raw vs. mitigated</a:t>
+              <a:t>3 problems side by side barely disturbed each other</a:t>
             </a:r>
             <a:endParaRPr lang="en-US" sz="1200" dirty="0"/>
           </a:p>

</xml_diff>